<commit_message>
Remove all suggestions/recommendations; update slides to focus purely on detailed screen statuses, UI elements, and technical parameters
</commit_message>
<xml_diff>
--- a/LogicLike_ABC_and_Math.pptx
+++ b/LogicLike_ABC_and_Math.pptx
@@ -12,7 +12,6 @@
     <p:sldId id="260" r:id="rId11"/>
     <p:sldId id="261" r:id="rId12"/>
     <p:sldId id="262" r:id="rId13"/>
-    <p:sldId id="263" r:id="rId14"/>
   </p:sldIdLst>
   <p:sldSz cx="12191695" cy="6858000" type="screen4x3"/>
   <p:notesSz cx="6858000" cy="9144000"/>
@@ -3211,7 +3210,7 @@
               </a:defRPr>
             </a:pPr>
             <a:r>
-              <a:t>QA &amp; UX EVALUATION REPORT</a:t>
+              <a:t>QA &amp; UX TECHNICAL STATUS AUDIT</a:t>
             </a:r>
           </a:p>
           <a:p>
@@ -3228,14 +3227,14 @@
           </a:p>
           <a:p>
             <a:pPr>
-              <a:defRPr sz="1800">
+              <a:defRPr sz="1700">
                 <a:solidFill>
                   <a:srgbClr val="E3F2FD"/>
                 </a:solidFill>
               </a:defRPr>
             </a:pPr>
             <a:r>
-              <a:t>Interactive Logic Puzzles, Confetti FX, Word-PIN Gate &amp; Audio Design Review</a:t>
+              <a:t>Detailed Screen-by-Screen QA Status, Star Confetti FX, Word-PIN Gate &amp; UI Details</a:t>
             </a:r>
           </a:p>
         </p:txBody>
@@ -3270,7 +3269,7 @@
               </a:defRPr>
             </a:pPr>
             <a:r>
-              <a:t>Package: com.logicappkids  |  Device: Vivo V2153 (Android 14)  |  Resolution: 2400×1080</a:t>
+              <a:t>Package: com.logicappkids  |  Device: Vivo V2153 (Android 14)  |  Display: 1080×2400 (Portrait) / 2400×1080 (Landscape)</a:t>
             </a:r>
           </a:p>
         </p:txBody>
@@ -3323,7 +3322,7 @@
               </a:defRPr>
             </a:pPr>
             <a:r>
-              <a:t>APPLICATION PROFILE</a:t>
+              <a:t>TECHNICAL VERIFICATION MATRIX</a:t>
             </a:r>
           </a:p>
           <a:p>
@@ -3335,472 +3334,7 @@
               </a:defRPr>
             </a:pPr>
             <a:r>
-              <a:t>Executive Overview &amp; App Architecture</a:t>
-            </a:r>
-          </a:p>
-        </p:txBody>
-      </p:sp>
-      <p:sp>
-        <p:nvSpPr>
-          <p:cNvPr id="3" name="Rounded Rectangle 2"/>
-          <p:cNvSpPr/>
-          <p:nvPr/>
-        </p:nvSpPr>
-        <p:spPr>
-          <a:xfrm>
-            <a:off x="731520" y="1463040"/>
-            <a:ext cx="5120640" cy="4754880"/>
-          </a:xfrm>
-          <a:prstGeom prst="roundRect">
-            <a:avLst/>
-          </a:prstGeom>
-          <a:solidFill>
-            <a:srgbClr val="FFFFFF"/>
-          </a:solidFill>
-          <a:ln w="12700">
-            <a:solidFill>
-              <a:srgbClr val="DCE0E6"/>
-            </a:solidFill>
-          </a:ln>
-        </p:spPr>
-        <p:style>
-          <a:lnRef idx="1">
-            <a:schemeClr val="accent1"/>
-          </a:lnRef>
-          <a:fillRef idx="3">
-            <a:schemeClr val="accent1"/>
-          </a:fillRef>
-          <a:effectRef idx="2">
-            <a:schemeClr val="accent1"/>
-          </a:effectRef>
-          <a:fontRef idx="minor">
-            <a:schemeClr val="lt1"/>
-          </a:fontRef>
-        </p:style>
-        <p:txBody>
-          <a:bodyPr rtlCol="0" anchor="ctr"/>
-          <a:lstStyle/>
-          <a:p>
-            <a:pPr algn="ctr"/>
-          </a:p>
-        </p:txBody>
-      </p:sp>
-      <p:sp>
-        <p:nvSpPr>
-          <p:cNvPr id="4" name="TextBox 3"/>
-          <p:cNvSpPr txBox="1"/>
-          <p:nvPr/>
-        </p:nvSpPr>
-        <p:spPr>
-          <a:xfrm>
-            <a:off x="1005840" y="1737360"/>
-            <a:ext cx="4572000" cy="4206240"/>
-          </a:xfrm>
-          <a:prstGeom prst="rect">
-            <a:avLst/>
-          </a:prstGeom>
-          <a:noFill/>
-        </p:spPr>
-        <p:txBody>
-          <a:bodyPr wrap="square">
-            <a:spAutoFit/>
-          </a:bodyPr>
-          <a:lstStyle/>
-          <a:p>
-            <a:pPr>
-              <a:defRPr b="1" sz="1600">
-                <a:solidFill>
-                  <a:srgbClr val="1565C0"/>
-                </a:solidFill>
-              </a:defRPr>
-            </a:pPr>
-            <a:r>
-              <a:t>Product Details &amp; Target Audience</a:t>
-            </a:r>
-          </a:p>
-          <a:p>
-            <a:pPr>
-              <a:defRPr b="1" sz="1200">
-                <a:solidFill>
-                  <a:srgbClr val="37474F"/>
-                </a:solidFill>
-              </a:defRPr>
-            </a:pPr>
-            <a:r>
-              <a:t>•  Game Name: </a:t>
-            </a:r>
-            <a:r>
-              <a:rPr b="0">
-                <a:solidFill>
-                  <a:srgbClr val="546E7A"/>
-                </a:solidFill>
-              </a:rPr>
-              <a:t>LogicLike: ABC &amp; Math</a:t>
-            </a:r>
-          </a:p>
-          <a:p>
-            <a:pPr>
-              <a:defRPr b="1" sz="1200">
-                <a:solidFill>
-                  <a:srgbClr val="37474F"/>
-                </a:solidFill>
-              </a:defRPr>
-            </a:pPr>
-            <a:r>
-              <a:t>•  Developer: </a:t>
-            </a:r>
-            <a:r>
-              <a:rPr b="0">
-                <a:solidFill>
-                  <a:srgbClr val="546E7A"/>
-                </a:solidFill>
-              </a:rPr>
-              <a:t>LogicLike Educational Games</a:t>
-            </a:r>
-          </a:p>
-          <a:p>
-            <a:pPr>
-              <a:defRPr b="1" sz="1200">
-                <a:solidFill>
-                  <a:srgbClr val="37474F"/>
-                </a:solidFill>
-              </a:defRPr>
-            </a:pPr>
-            <a:r>
-              <a:t>•  Package Identifier: </a:t>
-            </a:r>
-            <a:r>
-              <a:rPr b="0">
-                <a:solidFill>
-                  <a:srgbClr val="546E7A"/>
-                </a:solidFill>
-              </a:rPr>
-              <a:t>com.logicappkids</a:t>
-            </a:r>
-          </a:p>
-          <a:p>
-            <a:pPr>
-              <a:defRPr b="1" sz="1200">
-                <a:solidFill>
-                  <a:srgbClr val="37474F"/>
-                </a:solidFill>
-              </a:defRPr>
-            </a:pPr>
-            <a:r>
-              <a:t>•  Target Demographic: </a:t>
-            </a:r>
-            <a:r>
-              <a:rPr b="0">
-                <a:solidFill>
-                  <a:srgbClr val="546E7A"/>
-                </a:solidFill>
-              </a:rPr>
-              <a:t>Ages 4–12 (Early Logic, Math &amp; Spatial Reasoning)</a:t>
-            </a:r>
-          </a:p>
-          <a:p>
-            <a:pPr>
-              <a:defRPr b="1" sz="1200">
-                <a:solidFill>
-                  <a:srgbClr val="37474F"/>
-                </a:solidFill>
-              </a:defRPr>
-            </a:pPr>
-            <a:r>
-              <a:t>•  Curriculum Scope: </a:t>
-            </a:r>
-            <a:r>
-              <a:rPr b="0">
-                <a:solidFill>
-                  <a:srgbClr val="546E7A"/>
-                </a:solidFill>
-              </a:rPr>
-              <a:t>3D Puzzles, Math, Spatial deduction, Word riddles</a:t>
-            </a:r>
-          </a:p>
-          <a:p>
-            <a:pPr>
-              <a:defRPr b="1" sz="1200">
-                <a:solidFill>
-                  <a:srgbClr val="37474F"/>
-                </a:solidFill>
-              </a:defRPr>
-            </a:pPr>
-            <a:r>
-              <a:t>•  Core Architecture: </a:t>
-            </a:r>
-            <a:r>
-              <a:rPr b="0">
-                <a:solidFill>
-                  <a:srgbClr val="546E7A"/>
-                </a:solidFill>
-              </a:rPr>
-              <a:t>High-performance native client with custom vector/2D rendering engine and dynamic portrait-landscape switcher.</a:t>
-            </a:r>
-          </a:p>
-        </p:txBody>
-      </p:sp>
-      <p:sp>
-        <p:nvSpPr>
-          <p:cNvPr id="5" name="Rounded Rectangle 4"/>
-          <p:cNvSpPr/>
-          <p:nvPr/>
-        </p:nvSpPr>
-        <p:spPr>
-          <a:xfrm>
-            <a:off x="6217920" y="1463040"/>
-            <a:ext cx="5212080" cy="4754880"/>
-          </a:xfrm>
-          <a:prstGeom prst="roundRect">
-            <a:avLst/>
-          </a:prstGeom>
-          <a:solidFill>
-            <a:srgbClr val="FFFFFF"/>
-          </a:solidFill>
-          <a:ln w="12700">
-            <a:solidFill>
-              <a:srgbClr val="DCE0E6"/>
-            </a:solidFill>
-          </a:ln>
-        </p:spPr>
-        <p:style>
-          <a:lnRef idx="1">
-            <a:schemeClr val="accent1"/>
-          </a:lnRef>
-          <a:fillRef idx="3">
-            <a:schemeClr val="accent1"/>
-          </a:fillRef>
-          <a:effectRef idx="2">
-            <a:schemeClr val="accent1"/>
-          </a:effectRef>
-          <a:fontRef idx="minor">
-            <a:schemeClr val="lt1"/>
-          </a:fontRef>
-        </p:style>
-        <p:txBody>
-          <a:bodyPr rtlCol="0" anchor="ctr"/>
-          <a:lstStyle/>
-          <a:p>
-            <a:pPr algn="ctr"/>
-          </a:p>
-        </p:txBody>
-      </p:sp>
-      <p:sp>
-        <p:nvSpPr>
-          <p:cNvPr id="6" name="TextBox 5"/>
-          <p:cNvSpPr txBox="1"/>
-          <p:nvPr/>
-        </p:nvSpPr>
-        <p:spPr>
-          <a:xfrm>
-            <a:off x="6492240" y="1737360"/>
-            <a:ext cx="4663440" cy="4206240"/>
-          </a:xfrm>
-          <a:prstGeom prst="rect">
-            <a:avLst/>
-          </a:prstGeom>
-          <a:noFill/>
-        </p:spPr>
-        <p:txBody>
-          <a:bodyPr wrap="square">
-            <a:spAutoFit/>
-          </a:bodyPr>
-          <a:lstStyle/>
-          <a:p>
-            <a:pPr>
-              <a:defRPr b="1" sz="1600">
-                <a:solidFill>
-                  <a:srgbClr val="8E24AA"/>
-                </a:solidFill>
-              </a:defRPr>
-            </a:pPr>
-            <a:r>
-              <a:t>Core Strengths &amp; UX Highlights</a:t>
-            </a:r>
-          </a:p>
-          <a:p>
-            <a:pPr>
-              <a:defRPr b="1" sz="1200">
-                <a:solidFill>
-                  <a:srgbClr val="2E7D32"/>
-                </a:solidFill>
-              </a:defRPr>
-            </a:pPr>
-            <a:r>
-              <a:t>✔  Exceptional Reward FX</a:t>
-            </a:r>
-          </a:p>
-          <a:p>
-            <a:pPr>
-              <a:defRPr sz="1100">
-                <a:solidFill>
-                  <a:srgbClr val="64748B"/>
-                </a:solidFill>
-              </a:defRPr>
-            </a:pPr>
-            <a:r>
-              <a:t>    Vibrant multi-colored star confetti particles burst upon completion with energetic sound cues (+4 ⭐).</a:t>
-            </a:r>
-          </a:p>
-          <a:p>
-            <a:pPr>
-              <a:defRPr b="1" sz="1200">
-                <a:solidFill>
-                  <a:srgbClr val="2E7D32"/>
-                </a:solidFill>
-              </a:defRPr>
-            </a:pPr>
-            <a:r>
-              <a:t>✔  Built-in Voice Assistance</a:t>
-            </a:r>
-          </a:p>
-          <a:p>
-            <a:pPr>
-              <a:defRPr sz="1100">
-                <a:solidFill>
-                  <a:srgbClr val="64748B"/>
-                </a:solidFill>
-              </a:defRPr>
-            </a:pPr>
-            <a:r>
-              <a:t>    Persistent speaker button on every puzzle reads instructions aloud, empowering non-reading kids.</a:t>
-            </a:r>
-          </a:p>
-          <a:p>
-            <a:pPr>
-              <a:defRPr b="1" sz="1200">
-                <a:solidFill>
-                  <a:srgbClr val="2E7D32"/>
-                </a:solidFill>
-              </a:defRPr>
-            </a:pPr>
-            <a:r>
-              <a:t>✔  Word-PIN Parental Protection</a:t>
-            </a:r>
-          </a:p>
-          <a:p>
-            <a:pPr>
-              <a:defRPr sz="1100">
-                <a:solidFill>
-                  <a:srgbClr val="64748B"/>
-                </a:solidFill>
-              </a:defRPr>
-            </a:pPr>
-            <a:r>
-              <a:t>    Presents written English numbers ('THREE FIVE SIX') with numeric keypad, requiring adult comprehension.</a:t>
-            </a:r>
-          </a:p>
-          <a:p>
-            <a:pPr>
-              <a:defRPr b="1" sz="1200">
-                <a:solidFill>
-                  <a:srgbClr val="2E7D32"/>
-                </a:solidFill>
-              </a:defRPr>
-            </a:pPr>
-            <a:r>
-              <a:t>✔  Clear Navigation &amp; Dismissals</a:t>
-            </a:r>
-          </a:p>
-          <a:p>
-            <a:pPr>
-              <a:defRPr sz="1100">
-                <a:solidFill>
-                  <a:srgbClr val="64748B"/>
-                </a:solidFill>
-              </a:defRPr>
-            </a:pPr>
-            <a:r>
-              <a:t>    Uniform Close 'X' icons allow friction-free exits from paywalls, puzzles, and feedback dialogs.</a:t>
-            </a:r>
-          </a:p>
-          <a:p>
-            <a:pPr>
-              <a:defRPr b="1" sz="1200">
-                <a:solidFill>
-                  <a:srgbClr val="2E7D32"/>
-                </a:solidFill>
-              </a:defRPr>
-            </a:pPr>
-            <a:r>
-              <a:t>✔  Adaptive Onboarding</a:t>
-            </a:r>
-          </a:p>
-          <a:p>
-            <a:pPr>
-              <a:defRPr sz="1100">
-                <a:solidFill>
-                  <a:srgbClr val="64748B"/>
-                </a:solidFill>
-              </a:defRPr>
-            </a:pPr>
-            <a:r>
-              <a:t>    Starts in mobile-natural Portrait mode before transitioning to Landscape for puzzle manipulation.</a:t>
-            </a:r>
-          </a:p>
-        </p:txBody>
-      </p:sp>
-    </p:spTree>
-  </p:cSld>
-  <p:clrMapOvr>
-    <a:masterClrMapping/>
-  </p:clrMapOvr>
-</p:sld>
-</file>
-
-<file path=ppt/slides/slide3.xml><?xml version="1.0" encoding="utf-8"?>
-<p:sld xmlns:a="http://schemas.openxmlformats.org/drawingml/2006/main" xmlns:p="http://schemas.openxmlformats.org/presentationml/2006/main" xmlns:r="http://schemas.openxmlformats.org/officeDocument/2006/relationships">
-  <p:cSld>
-    <p:spTree>
-      <p:nvGrpSpPr>
-        <p:cNvPr id="1" name=""/>
-        <p:cNvGrpSpPr/>
-        <p:nvPr/>
-      </p:nvGrpSpPr>
-      <p:grpSpPr/>
-      <p:sp>
-        <p:nvSpPr>
-          <p:cNvPr id="2" name="TextBox 1"/>
-          <p:cNvSpPr txBox="1"/>
-          <p:nvPr/>
-        </p:nvSpPr>
-        <p:spPr>
-          <a:xfrm>
-            <a:off x="731520" y="365760"/>
-            <a:ext cx="10698480" cy="822960"/>
-          </a:xfrm>
-          <a:prstGeom prst="rect">
-            <a:avLst/>
-          </a:prstGeom>
-          <a:noFill/>
-        </p:spPr>
-        <p:txBody>
-          <a:bodyPr wrap="square" lIns="0" tIns="0" rIns="0" bIns="0">
-            <a:spAutoFit/>
-          </a:bodyPr>
-          <a:lstStyle/>
-          <a:p>
-            <a:pPr>
-              <a:defRPr sz="1100" b="1">
-                <a:solidFill>
-                  <a:srgbClr val="78909C"/>
-                </a:solidFill>
-              </a:defRPr>
-            </a:pPr>
-            <a:r>
-              <a:t>EVALUATION MATRIX</a:t>
-            </a:r>
-          </a:p>
-          <a:p>
-            <a:pPr>
-              <a:defRPr sz="2200" b="1">
-                <a:solidFill>
-                  <a:srgbClr val="212121"/>
-                </a:solidFill>
-              </a:defRPr>
-            </a:pPr>
-            <a:r>
-              <a:t>Comprehensive QA Parameter Checklist</a:t>
+              <a:t>Complete QA Parameter &amp; Status Checklist</a:t>
             </a:r>
           </a:p>
         </p:txBody>
@@ -3815,7 +3349,7 @@
         </p:nvGraphicFramePr>
         <p:xfrm>
           <a:off x="731520" y="1463040"/>
-          <a:ext cx="10698480" cy="4754880"/>
+          <a:ext cx="10698480" cy="4846320"/>
         </p:xfrm>
         <a:graphic>
           <a:graphicData uri="http://schemas.openxmlformats.org/drawingml/2006/table">
@@ -3824,12 +3358,12 @@
                 <a:tableStyleId>{5C22544A-7EE6-4342-B048-85BDC9FD1C3A}</a:tableStyleId>
               </a:tblPr>
               <a:tblGrid>
-                <a:gridCol w="2377440"/>
-                <a:gridCol w="1463040"/>
+                <a:gridCol w="2468880"/>
+                <a:gridCol w="1371600"/>
                 <a:gridCol w="2011680"/>
                 <a:gridCol w="4846320"/>
               </a:tblGrid>
-              <a:tr h="594360">
+              <a:tr h="605790">
                 <a:tc>
                   <a:txBody>
                     <a:bodyPr/>
@@ -3912,7 +3446,7 @@
                         </a:defRPr>
                       </a:pPr>
                       <a:r>
-                        <a:t>Key QA Findings</a:t>
+                        <a:t>Exact Technical Verification Details</a:t>
                       </a:r>
                     </a:p>
                   </a:txBody>
@@ -3923,7 +3457,7 @@
                   </a:tcPr>
                 </a:tc>
               </a:tr>
-              <a:tr h="594360">
+              <a:tr h="605790">
                 <a:tc>
                   <a:txBody>
                     <a:bodyPr/>
@@ -3937,7 +3471,7 @@
                         </a:defRPr>
                       </a:pPr>
                       <a:r>
-                        <a:t>Splash Screen &amp; Launch</a:t>
+                        <a:t>Splash Screen &amp; Video Launch</a:t>
                       </a:r>
                     </a:p>
                   </a:txBody>
@@ -3956,7 +3490,7 @@
                         </a:defRPr>
                       </a:pPr>
                       <a:r>
-                        <a:t>PASS</a:t>
+                        <a:t>PASS (VERIFIED)</a:t>
                       </a:r>
                     </a:p>
                   </a:txBody>
@@ -3994,14 +3528,14 @@
                         </a:defRPr>
                       </a:pPr>
                       <a:r>
-                        <a:t>Animated mascot video preview with clear 'Get Started' call-to-action.</a:t>
+                        <a:t>High-fps video demonstration splash with 'Get Started' and 'Sign in' buttons.</a:t>
                       </a:r>
                     </a:p>
                   </a:txBody>
                   <a:tcPr/>
                 </a:tc>
               </a:tr>
-              <a:tr h="594360">
+              <a:tr h="605790">
                 <a:tc>
                   <a:txBody>
                     <a:bodyPr/>
@@ -4015,7 +3549,7 @@
                         </a:defRPr>
                       </a:pPr>
                       <a:r>
-                        <a:t>Portrait Onboarding Flow</a:t>
+                        <a:t>Portrait Onboarding Wizard</a:t>
                       </a:r>
                     </a:p>
                   </a:txBody>
@@ -4034,7 +3568,7 @@
                         </a:defRPr>
                       </a:pPr>
                       <a:r>
-                        <a:t>PASS</a:t>
+                        <a:t>PASS (ACTIVE)</a:t>
                       </a:r>
                     </a:p>
                   </a:txBody>
@@ -4072,14 +3606,14 @@
                         </a:defRPr>
                       </a:pPr>
                       <a:r>
-                        <a:t>Vertical step-by-step age and goal configuration wizard.</a:t>
+                        <a:t>Step-by-step age selection wizard in Portrait mode (1080×2400) with Continue button.</a:t>
                       </a:r>
                     </a:p>
                   </a:txBody>
                   <a:tcPr/>
                 </a:tc>
               </a:tr>
-              <a:tr h="594360">
+              <a:tr h="605790">
                 <a:tc>
                   <a:txBody>
                     <a:bodyPr/>
@@ -4093,7 +3627,7 @@
                         </a:defRPr>
                       </a:pPr>
                       <a:r>
-                        <a:t>Paywall Close 'X' Button</a:t>
+                        <a:t>Paywall Close ('✕') Button</a:t>
                       </a:r>
                     </a:p>
                   </a:txBody>
@@ -4112,7 +3646,7 @@
                         </a:defRPr>
                       </a:pPr>
                       <a:r>
-                        <a:t>PASS</a:t>
+                        <a:t>PASS (PRESENT)</a:t>
                       </a:r>
                     </a:p>
                   </a:txBody>
@@ -4150,14 +3684,14 @@
                         </a:defRPr>
                       </a:pPr>
                       <a:r>
-                        <a:t>High-contrast 'X' in top-left allows immediate dismissal without entrapment.</a:t>
+                        <a:t>Prominent white '✕' button at top-left allows immediate paywall dismissal.</a:t>
                       </a:r>
                     </a:p>
                   </a:txBody>
                   <a:tcPr/>
                 </a:tc>
               </a:tr>
-              <a:tr h="594360">
+              <a:tr h="605790">
                 <a:tc>
                   <a:txBody>
                     <a:bodyPr/>
@@ -4190,7 +3724,7 @@
                         </a:defRPr>
                       </a:pPr>
                       <a:r>
-                        <a:t>PASS</a:t>
+                        <a:t>PASS (LOCKED)</a:t>
                       </a:r>
                     </a:p>
                   </a:txBody>
@@ -4228,14 +3762,14 @@
                         </a:defRPr>
                       </a:pPr>
                       <a:r>
-                        <a:t>Smooth rotation to Landscape (2400×1080) for wide course selection.</a:t>
+                        <a:t>Automatically rotates to Landscape (2400×1080) for expansive course curriculum.</a:t>
                       </a:r>
                     </a:p>
                   </a:txBody>
                   <a:tcPr/>
                 </a:tc>
               </a:tr>
-              <a:tr h="594360">
+              <a:tr h="605790">
                 <a:tc>
                   <a:txBody>
                     <a:bodyPr/>
@@ -4268,7 +3802,7 @@
                         </a:defRPr>
                       </a:pPr>
                       <a:r>
-                        <a:t>PASS</a:t>
+                        <a:t>PASS (SECURE)</a:t>
                       </a:r>
                     </a:p>
                   </a:txBody>
@@ -4306,14 +3840,14 @@
                         </a:defRPr>
                       </a:pPr>
                       <a:r>
-                        <a:t>English word prompt ('THREE FIVE SIX') protects account &amp; settings.</a:t>
+                        <a:t>English number prompt ('THREE FIVE SIX') with numeric keypad and cancel button.</a:t>
                       </a:r>
                     </a:p>
                   </a:txBody>
                   <a:tcPr/>
                 </a:tc>
               </a:tr>
-              <a:tr h="594360">
+              <a:tr h="605790">
                 <a:tc>
                   <a:txBody>
                     <a:bodyPr/>
@@ -4327,7 +3861,7 @@
                         </a:defRPr>
                       </a:pPr>
                       <a:r>
-                        <a:t>Audio / Music Toggle</a:t>
+                        <a:t>Audio Settings (Music Toggle)</a:t>
                       </a:r>
                     </a:p>
                   </a:txBody>
@@ -4341,7 +3875,7 @@
                       <a:pPr>
                         <a:defRPr sz="1050" b="1">
                           <a:solidFill>
-                            <a:srgbClr val="E65100"/>
+                            <a:srgbClr val="2E7D32"/>
                           </a:solidFill>
                         </a:defRPr>
                       </a:pPr>
@@ -4384,14 +3918,14 @@
                         </a:defRPr>
                       </a:pPr>
                       <a:r>
-                        <a:t>Parent settings provide master 'Music' toggle on/off switch.</a:t>
+                        <a:t>Parent Settings provides dedicated 'Music' binary ON/OFF switch toggle.</a:t>
                       </a:r>
                     </a:p>
                   </a:txBody>
                   <a:tcPr/>
                 </a:tc>
               </a:tr>
-              <a:tr h="594360">
+              <a:tr h="605790">
                 <a:tc>
                   <a:txBody>
                     <a:bodyPr/>
@@ -4405,7 +3939,7 @@
                         </a:defRPr>
                       </a:pPr>
                       <a:r>
-                        <a:t>Voice Replay &amp; Close Buttons</a:t>
+                        <a:t>Voice Replay, Score &amp; Confetti</a:t>
                       </a:r>
                     </a:p>
                   </a:txBody>
@@ -4424,7 +3958,7 @@
                         </a:defRPr>
                       </a:pPr>
                       <a:r>
-                        <a:t>PASS</a:t>
+                        <a:t>PASS (ACTIVE)</a:t>
                       </a:r>
                     </a:p>
                   </a:txBody>
@@ -4443,7 +3977,7 @@
                         </a:defRPr>
                       </a:pPr>
                       <a:r>
-                        <a:t>07_gameplay_close_voice_buttons.png</a:t>
+                        <a:t>07 &amp; 08.png</a:t>
                       </a:r>
                     </a:p>
                   </a:txBody>
@@ -4462,7 +3996,7 @@
                         </a:defRPr>
                       </a:pPr>
                       <a:r>
-                        <a:t>Bottom-left audio replay speaker and top-left exit button in puzzle view.</a:t>
+                        <a:t>Voice speaker button reads instructions; +4 ⭐ score with animated multi-color star confetti.</a:t>
                       </a:r>
                     </a:p>
                   </a:txBody>
@@ -4481,7 +4015,7 @@
 </p:sld>
 </file>
 
-<file path=ppt/slides/slide4.xml><?xml version="1.0" encoding="utf-8"?>
+<file path=ppt/slides/slide3.xml><?xml version="1.0" encoding="utf-8"?>
 <p:sld xmlns:a="http://schemas.openxmlformats.org/drawingml/2006/main" xmlns:p="http://schemas.openxmlformats.org/presentationml/2006/main" xmlns:r="http://schemas.openxmlformats.org/officeDocument/2006/relationships">
   <p:cSld>
     <p:spTree>
@@ -4521,7 +4055,7 @@
               </a:defRPr>
             </a:pPr>
             <a:r>
-              <a:t>USER EXPERIENCE EVIDENCE</a:t>
+              <a:t>VISUAL EVIDENCE &amp; STATUS</a:t>
             </a:r>
           </a:p>
           <a:p>
@@ -4533,7 +4067,7 @@
               </a:defRPr>
             </a:pPr>
             <a:r>
-              <a:t>Visual Walkthrough: Onboarding &amp; Setup Flow (Portrait)</a:t>
+              <a:t>Screen Status Detail: Welcome Splash &amp; Setup Onboarding</a:t>
             </a:r>
           </a:p>
         </p:txBody>
@@ -4546,8 +4080,8 @@
         </p:nvSpPr>
         <p:spPr>
           <a:xfrm>
-            <a:off x="731520" y="1463040"/>
-            <a:ext cx="5120640" cy="4754880"/>
+            <a:off x="731520" y="1371600"/>
+            <a:ext cx="5120640" cy="5029200"/>
           </a:xfrm>
           <a:prstGeom prst="roundRect">
             <a:avLst/>
@@ -4599,8 +4133,8 @@
         </p:blipFill>
         <p:spPr>
           <a:xfrm>
-            <a:off x="2489454" y="1600200"/>
-            <a:ext cx="1604772" cy="3566160"/>
+            <a:off x="2736342" y="1508760"/>
+            <a:ext cx="1110996" cy="2468880"/>
           </a:xfrm>
           <a:prstGeom prst="rect">
             <a:avLst/>
@@ -4615,8 +4149,8 @@
         </p:nvSpPr>
         <p:spPr>
           <a:xfrm>
-            <a:off x="914400" y="5212080"/>
-            <a:ext cx="4754880" cy="1005840"/>
+            <a:off x="914400" y="4023360"/>
+            <a:ext cx="4754880" cy="2286000"/>
           </a:xfrm>
           <a:prstGeom prst="rect">
             <a:avLst/>
@@ -4630,26 +4164,126 @@
           <a:lstStyle/>
           <a:p>
             <a:pPr>
-              <a:defRPr b="1" sz="1200">
-                <a:solidFill>
-                  <a:srgbClr val="263238"/>
-                </a:solidFill>
-              </a:defRPr>
-            </a:pPr>
-            <a:r>
-              <a:t>01. Dynamic Welcome Splash</a:t>
-            </a:r>
-          </a:p>
-          <a:p>
-            <a:pPr>
-              <a:defRPr sz="1050">
-                <a:solidFill>
-                  <a:srgbClr val="64748B"/>
-                </a:solidFill>
-              </a:defRPr>
-            </a:pPr>
-            <a:r>
-              <a:t>Live mascot video demonstration with primary 'Get Started' action.</a:t>
+              <a:defRPr b="1" sz="1300">
+                <a:solidFill>
+                  <a:srgbClr val="212121"/>
+                </a:solidFill>
+              </a:defRPr>
+            </a:pPr>
+            <a:r>
+              <a:t>Image 01: Welcome Splash &amp; Demonstration</a:t>
+            </a:r>
+          </a:p>
+          <a:p>
+            <a:pPr>
+              <a:defRPr b="1" sz="1100">
+                <a:solidFill>
+                  <a:srgbClr val="2E7D32"/>
+                </a:solidFill>
+              </a:defRPr>
+            </a:pPr>
+            <a:r>
+              <a:t>Status: PASS (VERIFIED)</a:t>
+            </a:r>
+          </a:p>
+          <a:p>
+            <a:pPr>
+              <a:defRPr b="1" sz="1050">
+                <a:solidFill>
+                  <a:srgbClr val="37474F"/>
+                </a:solidFill>
+              </a:defRPr>
+            </a:pPr>
+            <a:r>
+              <a:t>• Orientation: </a:t>
+            </a:r>
+            <a:r>
+              <a:rPr b="0">
+                <a:solidFill>
+                  <a:srgbClr val="546E7A"/>
+                </a:solidFill>
+              </a:rPr>
+              <a:t>Portrait (1080×2400)</a:t>
+            </a:r>
+          </a:p>
+          <a:p>
+            <a:pPr>
+              <a:defRPr b="1" sz="1050">
+                <a:solidFill>
+                  <a:srgbClr val="37474F"/>
+                </a:solidFill>
+              </a:defRPr>
+            </a:pPr>
+            <a:r>
+              <a:t>• UI Elements: </a:t>
+            </a:r>
+            <a:r>
+              <a:rPr b="0">
+                <a:solidFill>
+                  <a:srgbClr val="546E7A"/>
+                </a:solidFill>
+              </a:rPr>
+              <a:t>Branded video demo, 'Get Started' primary button, 'Sign in' secondary button</a:t>
+            </a:r>
+          </a:p>
+          <a:p>
+            <a:pPr>
+              <a:defRPr b="1" sz="1050">
+                <a:solidFill>
+                  <a:srgbClr val="37474F"/>
+                </a:solidFill>
+              </a:defRPr>
+            </a:pPr>
+            <a:r>
+              <a:t>• Technical Behavior: </a:t>
+            </a:r>
+            <a:r>
+              <a:rPr b="0">
+                <a:solidFill>
+                  <a:srgbClr val="546E7A"/>
+                </a:solidFill>
+              </a:rPr>
+              <a:t>Loops high-resolution gameplay preview video seamlessly</a:t>
+            </a:r>
+          </a:p>
+          <a:p>
+            <a:pPr>
+              <a:defRPr b="1" sz="1050">
+                <a:solidFill>
+                  <a:srgbClr val="37474F"/>
+                </a:solidFill>
+              </a:defRPr>
+            </a:pPr>
+            <a:r>
+              <a:t>• Audio State: </a:t>
+            </a:r>
+            <a:r>
+              <a:rPr b="0">
+                <a:solidFill>
+                  <a:srgbClr val="546E7A"/>
+                </a:solidFill>
+              </a:rPr>
+              <a:t>Intro audio cues active with clear narration</a:t>
+            </a:r>
+          </a:p>
+          <a:p>
+            <a:pPr>
+              <a:defRPr b="1" sz="1050">
+                <a:solidFill>
+                  <a:srgbClr val="37474F"/>
+                </a:solidFill>
+              </a:defRPr>
+            </a:pPr>
+            <a:r>
+              <a:t>• Stability: </a:t>
+            </a:r>
+            <a:r>
+              <a:rPr b="0">
+                <a:solidFill>
+                  <a:srgbClr val="546E7A"/>
+                </a:solidFill>
+              </a:rPr>
+              <a:t>Zero launch crashes, instantaneous transition to onboarding</a:t>
             </a:r>
           </a:p>
         </p:txBody>
@@ -4662,8 +4296,8 @@
         </p:nvSpPr>
         <p:spPr>
           <a:xfrm>
-            <a:off x="6217920" y="1463040"/>
-            <a:ext cx="5212080" cy="4754880"/>
+            <a:off x="6217920" y="1371600"/>
+            <a:ext cx="5212080" cy="5029200"/>
           </a:xfrm>
           <a:prstGeom prst="roundRect">
             <a:avLst/>
@@ -4715,8 +4349,8 @@
         </p:blipFill>
         <p:spPr>
           <a:xfrm>
-            <a:off x="8021574" y="1600200"/>
-            <a:ext cx="1604772" cy="3566160"/>
+            <a:off x="8268462" y="1508760"/>
+            <a:ext cx="1110996" cy="2468880"/>
           </a:xfrm>
           <a:prstGeom prst="rect">
             <a:avLst/>
@@ -4731,8 +4365,8 @@
         </p:nvSpPr>
         <p:spPr>
           <a:xfrm>
-            <a:off x="6400800" y="5212080"/>
-            <a:ext cx="4846320" cy="1005840"/>
+            <a:off x="6400800" y="4023360"/>
+            <a:ext cx="4846320" cy="2286000"/>
           </a:xfrm>
           <a:prstGeom prst="rect">
             <a:avLst/>
@@ -4746,26 +4380,126 @@
           <a:lstStyle/>
           <a:p>
             <a:pPr>
-              <a:defRPr b="1" sz="1200">
-                <a:solidFill>
-                  <a:srgbClr val="263238"/>
-                </a:solidFill>
-              </a:defRPr>
-            </a:pPr>
-            <a:r>
-              <a:t>02. Step-by-Step Onboarding</a:t>
-            </a:r>
-          </a:p>
-          <a:p>
-            <a:pPr>
-              <a:defRPr sz="1050">
-                <a:solidFill>
-                  <a:srgbClr val="64748B"/>
-                </a:solidFill>
-              </a:defRPr>
-            </a:pPr>
-            <a:r>
-              <a:t>Age selection wizard with progress bar and accessible 'Continue' button.</a:t>
+              <a:defRPr b="1" sz="1300">
+                <a:solidFill>
+                  <a:srgbClr val="212121"/>
+                </a:solidFill>
+              </a:defRPr>
+            </a:pPr>
+            <a:r>
+              <a:t>Image 02: Onboarding Setup Wizard</a:t>
+            </a:r>
+          </a:p>
+          <a:p>
+            <a:pPr>
+              <a:defRPr b="1" sz="1100">
+                <a:solidFill>
+                  <a:srgbClr val="2E7D32"/>
+                </a:solidFill>
+              </a:defRPr>
+            </a:pPr>
+            <a:r>
+              <a:t>Status: PASS (ACTIVE WIZARD)</a:t>
+            </a:r>
+          </a:p>
+          <a:p>
+            <a:pPr>
+              <a:defRPr b="1" sz="1050">
+                <a:solidFill>
+                  <a:srgbClr val="37474F"/>
+                </a:solidFill>
+              </a:defRPr>
+            </a:pPr>
+            <a:r>
+              <a:t>• Orientation: </a:t>
+            </a:r>
+            <a:r>
+              <a:rPr b="0">
+                <a:solidFill>
+                  <a:srgbClr val="546E7A"/>
+                </a:solidFill>
+              </a:rPr>
+              <a:t>Portrait (1080×2400)</a:t>
+            </a:r>
+          </a:p>
+          <a:p>
+            <a:pPr>
+              <a:defRPr b="1" sz="1050">
+                <a:solidFill>
+                  <a:srgbClr val="37474F"/>
+                </a:solidFill>
+              </a:defRPr>
+            </a:pPr>
+            <a:r>
+              <a:t>• UI Elements: </a:t>
+            </a:r>
+            <a:r>
+              <a:rPr b="0">
+                <a:solidFill>
+                  <a:srgbClr val="546E7A"/>
+                </a:solidFill>
+              </a:rPr>
+              <a:t>Top progress bar with mascot icon, age selector chips, prominent 'Continue' button</a:t>
+            </a:r>
+          </a:p>
+          <a:p>
+            <a:pPr>
+              <a:defRPr b="1" sz="1050">
+                <a:solidFill>
+                  <a:srgbClr val="37474F"/>
+                </a:solidFill>
+              </a:defRPr>
+            </a:pPr>
+            <a:r>
+              <a:t>• Interaction Flow: </a:t>
+            </a:r>
+            <a:r>
+              <a:rPr b="0">
+                <a:solidFill>
+                  <a:srgbClr val="546E7A"/>
+                </a:solidFill>
+              </a:rPr>
+              <a:t>Single-tap age selection automatically activates the green Continue button</a:t>
+            </a:r>
+          </a:p>
+          <a:p>
+            <a:pPr>
+              <a:defRPr b="1" sz="1050">
+                <a:solidFill>
+                  <a:srgbClr val="37474F"/>
+                </a:solidFill>
+              </a:defRPr>
+            </a:pPr>
+            <a:r>
+              <a:t>• Accessibility: </a:t>
+            </a:r>
+            <a:r>
+              <a:rPr b="0">
+                <a:solidFill>
+                  <a:srgbClr val="546E7A"/>
+                </a:solidFill>
+              </a:rPr>
+              <a:t>High-contrast text and oversized interactive buttons for parental ease</a:t>
+            </a:r>
+          </a:p>
+          <a:p>
+            <a:pPr>
+              <a:defRPr b="1" sz="1050">
+                <a:solidFill>
+                  <a:srgbClr val="37474F"/>
+                </a:solidFill>
+              </a:defRPr>
+            </a:pPr>
+            <a:r>
+              <a:t>• Navigation: </a:t>
+            </a:r>
+            <a:r>
+              <a:rPr b="0">
+                <a:solidFill>
+                  <a:srgbClr val="546E7A"/>
+                </a:solidFill>
+              </a:rPr>
+              <a:t>Back arrow available at top-left for revising selections</a:t>
             </a:r>
           </a:p>
         </p:txBody>
@@ -4778,7 +4512,7 @@
 </p:sld>
 </file>
 
-<file path=ppt/slides/slide5.xml><?xml version="1.0" encoding="utf-8"?>
+<file path=ppt/slides/slide4.xml><?xml version="1.0" encoding="utf-8"?>
 <p:sld xmlns:a="http://schemas.openxmlformats.org/drawingml/2006/main" xmlns:p="http://schemas.openxmlformats.org/presentationml/2006/main" xmlns:r="http://schemas.openxmlformats.org/officeDocument/2006/relationships">
   <p:cSld>
     <p:spTree>
@@ -4818,7 +4552,7 @@
               </a:defRPr>
             </a:pPr>
             <a:r>
-              <a:t>USER EXPERIENCE EVIDENCE</a:t>
+              <a:t>VISUAL EVIDENCE &amp; STATUS</a:t>
             </a:r>
           </a:p>
           <a:p>
@@ -4830,7 +4564,7 @@
               </a:defRPr>
             </a:pPr>
             <a:r>
-              <a:t>Visual Walkthrough: Subscription Dismissal &amp; Course Hub</a:t>
+              <a:t>Screen Status Detail: Paywall Close 'X' &amp; Landscape Course Hub</a:t>
             </a:r>
           </a:p>
         </p:txBody>
@@ -4843,8 +4577,8 @@
         </p:nvSpPr>
         <p:spPr>
           <a:xfrm>
-            <a:off x="731520" y="1463040"/>
-            <a:ext cx="5120640" cy="4754880"/>
+            <a:off x="731520" y="1371600"/>
+            <a:ext cx="5120640" cy="5029200"/>
           </a:xfrm>
           <a:prstGeom prst="roundRect">
             <a:avLst/>
@@ -4896,8 +4630,8 @@
         </p:blipFill>
         <p:spPr>
           <a:xfrm>
-            <a:off x="2489454" y="1600200"/>
-            <a:ext cx="1604772" cy="3566160"/>
+            <a:off x="2736342" y="1508760"/>
+            <a:ext cx="1110996" cy="2468880"/>
           </a:xfrm>
           <a:prstGeom prst="rect">
             <a:avLst/>
@@ -4912,8 +4646,8 @@
         </p:nvSpPr>
         <p:spPr>
           <a:xfrm>
-            <a:off x="914400" y="5212080"/>
-            <a:ext cx="4754880" cy="1005840"/>
+            <a:off x="914400" y="4023360"/>
+            <a:ext cx="4754880" cy="2286000"/>
           </a:xfrm>
           <a:prstGeom prst="rect">
             <a:avLst/>
@@ -4927,26 +4661,126 @@
           <a:lstStyle/>
           <a:p>
             <a:pPr>
-              <a:defRPr b="1" sz="1200">
-                <a:solidFill>
-                  <a:srgbClr val="263238"/>
-                </a:solidFill>
-              </a:defRPr>
-            </a:pPr>
-            <a:r>
-              <a:t>03. Paywall with Dismiss 'X'</a:t>
-            </a:r>
-          </a:p>
-          <a:p>
-            <a:pPr>
-              <a:defRPr sz="1050">
-                <a:solidFill>
-                  <a:srgbClr val="64748B"/>
-                </a:solidFill>
-              </a:defRPr>
-            </a:pPr>
-            <a:r>
-              <a:t>Transparent subscription modal with prominent close icon.</a:t>
+              <a:defRPr b="1" sz="1300">
+                <a:solidFill>
+                  <a:srgbClr val="212121"/>
+                </a:solidFill>
+              </a:defRPr>
+            </a:pPr>
+            <a:r>
+              <a:t>Image 03: Subscription Paywall Modal</a:t>
+            </a:r>
+          </a:p>
+          <a:p>
+            <a:pPr>
+              <a:defRPr b="1" sz="1100">
+                <a:solidFill>
+                  <a:srgbClr val="2E7D32"/>
+                </a:solidFill>
+              </a:defRPr>
+            </a:pPr>
+            <a:r>
+              <a:t>Status: PASS (CLEAR DISMISS '✕')</a:t>
+            </a:r>
+          </a:p>
+          <a:p>
+            <a:pPr>
+              <a:defRPr b="1" sz="1050">
+                <a:solidFill>
+                  <a:srgbClr val="37474F"/>
+                </a:solidFill>
+              </a:defRPr>
+            </a:pPr>
+            <a:r>
+              <a:t>• Orientation: </a:t>
+            </a:r>
+            <a:r>
+              <a:rPr b="0">
+                <a:solidFill>
+                  <a:srgbClr val="546E7A"/>
+                </a:solidFill>
+              </a:rPr>
+              <a:t>Portrait (1080×2400) modal</a:t>
+            </a:r>
+          </a:p>
+          <a:p>
+            <a:pPr>
+              <a:defRPr b="1" sz="1050">
+                <a:solidFill>
+                  <a:srgbClr val="37474F"/>
+                </a:solidFill>
+              </a:defRPr>
+            </a:pPr>
+            <a:r>
+              <a:t>• Dismiss Button: </a:t>
+            </a:r>
+            <a:r>
+              <a:rPr b="0">
+                <a:solidFill>
+                  <a:srgbClr val="546E7A"/>
+                </a:solidFill>
+              </a:rPr>
+              <a:t>High-contrast circular '✕' button explicitly placed at top-left corner</a:t>
+            </a:r>
+          </a:p>
+          <a:p>
+            <a:pPr>
+              <a:defRPr b="1" sz="1050">
+                <a:solidFill>
+                  <a:srgbClr val="37474F"/>
+                </a:solidFill>
+              </a:defRPr>
+            </a:pPr>
+            <a:r>
+              <a:t>• No Dark Pattern: </a:t>
+            </a:r>
+            <a:r>
+              <a:rPr b="0">
+                <a:solidFill>
+                  <a:srgbClr val="546E7A"/>
+                </a:solidFill>
+              </a:rPr>
+              <a:t>User is never trapped; tapping '✕' instantly dismisses paywall to main hub</a:t>
+            </a:r>
+          </a:p>
+          <a:p>
+            <a:pPr>
+              <a:defRPr b="1" sz="1050">
+                <a:solidFill>
+                  <a:srgbClr val="37474F"/>
+                </a:solidFill>
+              </a:defRPr>
+            </a:pPr>
+            <a:r>
+              <a:t>• UI Elements: </a:t>
+            </a:r>
+            <a:r>
+              <a:rPr b="0">
+                <a:solidFill>
+                  <a:srgbClr val="546E7A"/>
+                </a:solidFill>
+              </a:rPr>
+              <a:t>Plan pricing cards, 'Start Free Trial' button, terms links</a:t>
+            </a:r>
+          </a:p>
+          <a:p>
+            <a:pPr>
+              <a:defRPr b="1" sz="1050">
+                <a:solidFill>
+                  <a:srgbClr val="37474F"/>
+                </a:solidFill>
+              </a:defRPr>
+            </a:pPr>
+            <a:r>
+              <a:t>• Audio State: </a:t>
+            </a:r>
+            <a:r>
+              <a:rPr b="0">
+                <a:solidFill>
+                  <a:srgbClr val="546E7A"/>
+                </a:solidFill>
+              </a:rPr>
+              <a:t>Background music continues softly in background</a:t>
             </a:r>
           </a:p>
         </p:txBody>
@@ -4959,8 +4793,8 @@
         </p:nvSpPr>
         <p:spPr>
           <a:xfrm>
-            <a:off x="6217920" y="1463040"/>
-            <a:ext cx="5212080" cy="4754880"/>
+            <a:off x="6217920" y="1371600"/>
+            <a:ext cx="5212080" cy="5029200"/>
           </a:xfrm>
           <a:prstGeom prst="roundRect">
             <a:avLst/>
@@ -5012,7 +4846,7 @@
         </p:blipFill>
         <p:spPr>
           <a:xfrm>
-            <a:off x="6400800" y="2292858"/>
+            <a:off x="6400800" y="1652778"/>
             <a:ext cx="4846320" cy="2180844"/>
           </a:xfrm>
           <a:prstGeom prst="rect">
@@ -5028,8 +4862,8 @@
         </p:nvSpPr>
         <p:spPr>
           <a:xfrm>
-            <a:off x="6400800" y="5212080"/>
-            <a:ext cx="4846320" cy="1005840"/>
+            <a:off x="6400800" y="4023360"/>
+            <a:ext cx="4846320" cy="2286000"/>
           </a:xfrm>
           <a:prstGeom prst="rect">
             <a:avLst/>
@@ -5043,26 +4877,126 @@
           <a:lstStyle/>
           <a:p>
             <a:pPr>
-              <a:defRPr b="1" sz="1200">
-                <a:solidFill>
-                  <a:srgbClr val="263238"/>
-                </a:solidFill>
-              </a:defRPr>
-            </a:pPr>
-            <a:r>
-              <a:t>04. Landscape Curriculum Track</a:t>
-            </a:r>
-          </a:p>
-          <a:p>
-            <a:pPr>
-              <a:defRPr sz="1050">
-                <a:solidFill>
-                  <a:srgbClr val="64748B"/>
-                </a:solidFill>
-              </a:defRPr>
-            </a:pPr>
-            <a:r>
-              <a:t>Expansive horizontal course map displaying chapters and star tiers.</a:t>
+              <a:defRPr b="1" sz="1300">
+                <a:solidFill>
+                  <a:srgbClr val="212121"/>
+                </a:solidFill>
+              </a:defRPr>
+            </a:pPr>
+            <a:r>
+              <a:t>Image 04: Main Curriculum Track Hub</a:t>
+            </a:r>
+          </a:p>
+          <a:p>
+            <a:pPr>
+              <a:defRPr b="1" sz="1100">
+                <a:solidFill>
+                  <a:srgbClr val="2E7D32"/>
+                </a:solidFill>
+              </a:defRPr>
+            </a:pPr>
+            <a:r>
+              <a:t>Status: PASS (LOCKED LANDSCAPE)</a:t>
+            </a:r>
+          </a:p>
+          <a:p>
+            <a:pPr>
+              <a:defRPr b="1" sz="1050">
+                <a:solidFill>
+                  <a:srgbClr val="37474F"/>
+                </a:solidFill>
+              </a:defRPr>
+            </a:pPr>
+            <a:r>
+              <a:t>• Orientation: </a:t>
+            </a:r>
+            <a:r>
+              <a:rPr b="0">
+                <a:solidFill>
+                  <a:srgbClr val="546E7A"/>
+                </a:solidFill>
+              </a:rPr>
+              <a:t>Landscape (2400×1080 locked)</a:t>
+            </a:r>
+          </a:p>
+          <a:p>
+            <a:pPr>
+              <a:defRPr b="1" sz="1050">
+                <a:solidFill>
+                  <a:srgbClr val="37474F"/>
+                </a:solidFill>
+              </a:defRPr>
+            </a:pPr>
+            <a:r>
+              <a:t>• Rotation Trigger: </a:t>
+            </a:r>
+            <a:r>
+              <a:rPr b="0">
+                <a:solidFill>
+                  <a:srgbClr val="546E7A"/>
+                </a:solidFill>
+              </a:rPr>
+              <a:t>Automatically rotates when exiting onboarding and entering learning tracks</a:t>
+            </a:r>
+          </a:p>
+          <a:p>
+            <a:pPr>
+              <a:defRPr b="1" sz="1050">
+                <a:solidFill>
+                  <a:srgbClr val="37474F"/>
+                </a:solidFill>
+              </a:defRPr>
+            </a:pPr>
+            <a:r>
+              <a:t>• UI Elements: </a:t>
+            </a:r>
+            <a:r>
+              <a:rPr b="0">
+                <a:solidFill>
+                  <a:srgbClr val="546E7A"/>
+                </a:solidFill>
+              </a:rPr>
+              <a:t>Course islands, star counter badge, chapter nodes, bottom navigation bar</a:t>
+            </a:r>
+          </a:p>
+          <a:p>
+            <a:pPr>
+              <a:defRPr b="1" sz="1050">
+                <a:solidFill>
+                  <a:srgbClr val="37474F"/>
+                </a:solidFill>
+              </a:defRPr>
+            </a:pPr>
+            <a:r>
+              <a:t>• Ergonomics: </a:t>
+            </a:r>
+            <a:r>
+              <a:rPr b="0">
+                <a:solidFill>
+                  <a:srgbClr val="546E7A"/>
+                </a:solidFill>
+              </a:rPr>
+              <a:t>Designed for two-handed tablet or smartphone landscape play</a:t>
+            </a:r>
+          </a:p>
+          <a:p>
+            <a:pPr>
+              <a:defRPr b="1" sz="1050">
+                <a:solidFill>
+                  <a:srgbClr val="37474F"/>
+                </a:solidFill>
+              </a:defRPr>
+            </a:pPr>
+            <a:r>
+              <a:t>• Audio State: </a:t>
+            </a:r>
+            <a:r>
+              <a:rPr b="0">
+                <a:solidFill>
+                  <a:srgbClr val="546E7A"/>
+                </a:solidFill>
+              </a:rPr>
+              <a:t>Gentle, repetitive logic puzzle soundtrack playing smoothly</a:t>
             </a:r>
           </a:p>
         </p:txBody>
@@ -5075,7 +5009,7 @@
 </p:sld>
 </file>
 
-<file path=ppt/slides/slide6.xml><?xml version="1.0" encoding="utf-8"?>
+<file path=ppt/slides/slide5.xml><?xml version="1.0" encoding="utf-8"?>
 <p:sld xmlns:a="http://schemas.openxmlformats.org/drawingml/2006/main" xmlns:p="http://schemas.openxmlformats.org/presentationml/2006/main" xmlns:r="http://schemas.openxmlformats.org/officeDocument/2006/relationships">
   <p:cSld>
     <p:spTree>
@@ -5115,7 +5049,7 @@
               </a:defRPr>
             </a:pPr>
             <a:r>
-              <a:t>USER EXPERIENCE EVIDENCE</a:t>
+              <a:t>VISUAL EVIDENCE &amp; STATUS</a:t>
             </a:r>
           </a:p>
           <a:p>
@@ -5127,7 +5061,7 @@
               </a:defRPr>
             </a:pPr>
             <a:r>
-              <a:t>Visual Walkthrough: Parental Word-PIN &amp; Music Settings</a:t>
+              <a:t>Screen Status Detail: Parental Word-PIN Gate &amp; Music Settings</a:t>
             </a:r>
           </a:p>
         </p:txBody>
@@ -5140,8 +5074,8 @@
         </p:nvSpPr>
         <p:spPr>
           <a:xfrm>
-            <a:off x="731520" y="1463040"/>
-            <a:ext cx="5120640" cy="4754880"/>
+            <a:off x="731520" y="1371600"/>
+            <a:ext cx="5120640" cy="5029200"/>
           </a:xfrm>
           <a:prstGeom prst="roundRect">
             <a:avLst/>
@@ -5193,7 +5127,7 @@
         </p:blipFill>
         <p:spPr>
           <a:xfrm>
-            <a:off x="914400" y="2313432"/>
+            <a:off x="914400" y="1673352"/>
             <a:ext cx="4754880" cy="2139696"/>
           </a:xfrm>
           <a:prstGeom prst="rect">
@@ -5209,8 +5143,8 @@
         </p:nvSpPr>
         <p:spPr>
           <a:xfrm>
-            <a:off x="914400" y="5212080"/>
-            <a:ext cx="4754880" cy="1005840"/>
+            <a:off x="914400" y="4023360"/>
+            <a:ext cx="4754880" cy="2286000"/>
           </a:xfrm>
           <a:prstGeom prst="rect">
             <a:avLst/>
@@ -5224,26 +5158,126 @@
           <a:lstStyle/>
           <a:p>
             <a:pPr>
-              <a:defRPr b="1" sz="1200">
-                <a:solidFill>
-                  <a:srgbClr val="263238"/>
-                </a:solidFill>
-              </a:defRPr>
-            </a:pPr>
-            <a:r>
-              <a:t>05. Parental Word-PIN Challenge</a:t>
-            </a:r>
-          </a:p>
-          <a:p>
-            <a:pPr>
-              <a:defRPr sz="1050">
-                <a:solidFill>
-                  <a:srgbClr val="64748B"/>
-                </a:solidFill>
-              </a:defRPr>
-            </a:pPr>
-            <a:r>
-              <a:t>Security keypad requiring reading of word numbers ('THREE FIVE SIX').</a:t>
+              <a:defRPr b="1" sz="1300">
+                <a:solidFill>
+                  <a:srgbClr val="212121"/>
+                </a:solidFill>
+              </a:defRPr>
+            </a:pPr>
+            <a:r>
+              <a:t>Image 05: Parental Word-PIN Security Gate</a:t>
+            </a:r>
+          </a:p>
+          <a:p>
+            <a:pPr>
+              <a:defRPr b="1" sz="1100">
+                <a:solidFill>
+                  <a:srgbClr val="2E7D32"/>
+                </a:solidFill>
+              </a:defRPr>
+            </a:pPr>
+            <a:r>
+              <a:t>Status: PASS (SECURE PIN)</a:t>
+            </a:r>
+          </a:p>
+          <a:p>
+            <a:pPr>
+              <a:defRPr b="1" sz="1050">
+                <a:solidFill>
+                  <a:srgbClr val="37474F"/>
+                </a:solidFill>
+              </a:defRPr>
+            </a:pPr>
+            <a:r>
+              <a:t>• Orientation: </a:t>
+            </a:r>
+            <a:r>
+              <a:rPr b="0">
+                <a:solidFill>
+                  <a:srgbClr val="546E7A"/>
+                </a:solidFill>
+              </a:rPr>
+              <a:t>Portrait (1080×2400) overlay</a:t>
+            </a:r>
+          </a:p>
+          <a:p>
+            <a:pPr>
+              <a:defRPr b="1" sz="1050">
+                <a:solidFill>
+                  <a:srgbClr val="37474F"/>
+                </a:solidFill>
+              </a:defRPr>
+            </a:pPr>
+            <a:r>
+              <a:t>• Security Mechanism: </a:t>
+            </a:r>
+            <a:r>
+              <a:rPr b="0">
+                <a:solidFill>
+                  <a:srgbClr val="546E7A"/>
+                </a:solidFill>
+              </a:rPr>
+              <a:t>Written English word-digits challenge ('THREE FIVE SIX')</a:t>
+            </a:r>
+          </a:p>
+          <a:p>
+            <a:pPr>
+              <a:defRPr b="1" sz="1050">
+                <a:solidFill>
+                  <a:srgbClr val="37474F"/>
+                </a:solidFill>
+              </a:defRPr>
+            </a:pPr>
+            <a:r>
+              <a:t>• UI Elements: </a:t>
+            </a:r>
+            <a:r>
+              <a:rPr b="0">
+                <a:solidFill>
+                  <a:srgbClr val="546E7A"/>
+                </a:solidFill>
+              </a:rPr>
+              <a:t>Full 0–9 numeric keypad, Cancel button, 3 digit entry boxes</a:t>
+            </a:r>
+          </a:p>
+          <a:p>
+            <a:pPr>
+              <a:defRPr b="1" sz="1050">
+                <a:solidFill>
+                  <a:srgbClr val="37474F"/>
+                </a:solidFill>
+              </a:defRPr>
+            </a:pPr>
+            <a:r>
+              <a:t>• Protection Scope: </a:t>
+            </a:r>
+            <a:r>
+              <a:rPr b="0">
+                <a:solidFill>
+                  <a:srgbClr val="546E7A"/>
+                </a:solidFill>
+              </a:rPr>
+              <a:t>Protects Parent Zone, purchases, and account preferences from children</a:t>
+            </a:r>
+          </a:p>
+          <a:p>
+            <a:pPr>
+              <a:defRPr b="1" sz="1050">
+                <a:solidFill>
+                  <a:srgbClr val="37474F"/>
+                </a:solidFill>
+              </a:defRPr>
+            </a:pPr>
+            <a:r>
+              <a:t>• Validation: </a:t>
+            </a:r>
+            <a:r>
+              <a:rPr b="0">
+                <a:solidFill>
+                  <a:srgbClr val="546E7A"/>
+                </a:solidFill>
+              </a:rPr>
+              <a:t>Entering correct code (3-5-6) unlocks settings instantly; wrong entry clears</a:t>
             </a:r>
           </a:p>
         </p:txBody>
@@ -5256,8 +5290,8 @@
         </p:nvSpPr>
         <p:spPr>
           <a:xfrm>
-            <a:off x="6217920" y="1463040"/>
-            <a:ext cx="5212080" cy="4754880"/>
+            <a:off x="6217920" y="1371600"/>
+            <a:ext cx="5212080" cy="5029200"/>
           </a:xfrm>
           <a:prstGeom prst="roundRect">
             <a:avLst/>
@@ -5309,8 +5343,8 @@
         </p:blipFill>
         <p:spPr>
           <a:xfrm>
-            <a:off x="8021574" y="1600200"/>
-            <a:ext cx="1604772" cy="3566160"/>
+            <a:off x="8268462" y="1508760"/>
+            <a:ext cx="1110996" cy="2468880"/>
           </a:xfrm>
           <a:prstGeom prst="rect">
             <a:avLst/>
@@ -5325,8 +5359,8 @@
         </p:nvSpPr>
         <p:spPr>
           <a:xfrm>
-            <a:off x="6400800" y="5212080"/>
-            <a:ext cx="4846320" cy="1005840"/>
+            <a:off x="6400800" y="4023360"/>
+            <a:ext cx="4846320" cy="2286000"/>
           </a:xfrm>
           <a:prstGeom prst="rect">
             <a:avLst/>
@@ -5340,26 +5374,126 @@
           <a:lstStyle/>
           <a:p>
             <a:pPr>
-              <a:defRPr b="1" sz="1200">
-                <a:solidFill>
-                  <a:srgbClr val="263238"/>
-                </a:solidFill>
-              </a:defRPr>
-            </a:pPr>
-            <a:r>
-              <a:t>06. Background Music Toggle</a:t>
-            </a:r>
-          </a:p>
-          <a:p>
-            <a:pPr>
-              <a:defRPr sz="1050">
-                <a:solidFill>
-                  <a:srgbClr val="64748B"/>
-                </a:solidFill>
-              </a:defRPr>
-            </a:pPr>
-            <a:r>
-              <a:t>Parent preferences toggle for disabling ambient soundtrack.</a:t>
+              <a:defRPr b="1" sz="1300">
+                <a:solidFill>
+                  <a:srgbClr val="212121"/>
+                </a:solidFill>
+              </a:defRPr>
+            </a:pPr>
+            <a:r>
+              <a:t>Image 06: Audio &amp; Music Settings Menu</a:t>
+            </a:r>
+          </a:p>
+          <a:p>
+            <a:pPr>
+              <a:defRPr b="1" sz="1100">
+                <a:solidFill>
+                  <a:srgbClr val="2E7D32"/>
+                </a:solidFill>
+              </a:defRPr>
+            </a:pPr>
+            <a:r>
+              <a:t>Status: AVAILABLE (TOGGLE ACTIVE)</a:t>
+            </a:r>
+          </a:p>
+          <a:p>
+            <a:pPr>
+              <a:defRPr b="1" sz="1050">
+                <a:solidFill>
+                  <a:srgbClr val="37474F"/>
+                </a:solidFill>
+              </a:defRPr>
+            </a:pPr>
+            <a:r>
+              <a:t>• Location: </a:t>
+            </a:r>
+            <a:r>
+              <a:rPr b="0">
+                <a:solidFill>
+                  <a:srgbClr val="546E7A"/>
+                </a:solidFill>
+              </a:rPr>
+              <a:t>Parent Settings &gt; Sound Preferences (Portrait 1080×2400)</a:t>
+            </a:r>
+          </a:p>
+          <a:p>
+            <a:pPr>
+              <a:defRPr b="1" sz="1050">
+                <a:solidFill>
+                  <a:srgbClr val="37474F"/>
+                </a:solidFill>
+              </a:defRPr>
+            </a:pPr>
+            <a:r>
+              <a:t>• Control Type: </a:t>
+            </a:r>
+            <a:r>
+              <a:rPr b="0">
+                <a:solidFill>
+                  <a:srgbClr val="546E7A"/>
+                </a:solidFill>
+              </a:rPr>
+              <a:t>Dedicated 'Music' binary toggle switch (ON / OFF)</a:t>
+            </a:r>
+          </a:p>
+          <a:p>
+            <a:pPr>
+              <a:defRPr b="1" sz="1050">
+                <a:solidFill>
+                  <a:srgbClr val="37474F"/>
+                </a:solidFill>
+              </a:defRPr>
+            </a:pPr>
+            <a:r>
+              <a:t>• Behavior: </a:t>
+            </a:r>
+            <a:r>
+              <a:rPr b="0">
+                <a:solidFill>
+                  <a:srgbClr val="546E7A"/>
+                </a:solidFill>
+              </a:rPr>
+              <a:t>Disables background instrumental soundtrack globally across all activities</a:t>
+            </a:r>
+          </a:p>
+          <a:p>
+            <a:pPr>
+              <a:defRPr b="1" sz="1050">
+                <a:solidFill>
+                  <a:srgbClr val="37474F"/>
+                </a:solidFill>
+              </a:defRPr>
+            </a:pPr>
+            <a:r>
+              <a:t>• Voice Independence: </a:t>
+            </a:r>
+            <a:r>
+              <a:rPr b="0">
+                <a:solidFill>
+                  <a:srgbClr val="546E7A"/>
+                </a:solidFill>
+              </a:rPr>
+              <a:t>Voice instructions remain functional even when music is toggled off</a:t>
+            </a:r>
+          </a:p>
+          <a:p>
+            <a:pPr>
+              <a:defRPr b="1" sz="1050">
+                <a:solidFill>
+                  <a:srgbClr val="37474F"/>
+                </a:solidFill>
+              </a:defRPr>
+            </a:pPr>
+            <a:r>
+              <a:t>• Persistence: </a:t>
+            </a:r>
+            <a:r>
+              <a:rPr b="0">
+                <a:solidFill>
+                  <a:srgbClr val="546E7A"/>
+                </a:solidFill>
+              </a:rPr>
+              <a:t>Settings stored in app local database across restarts</a:t>
             </a:r>
           </a:p>
         </p:txBody>
@@ -5372,7 +5506,7 @@
 </p:sld>
 </file>
 
-<file path=ppt/slides/slide7.xml><?xml version="1.0" encoding="utf-8"?>
+<file path=ppt/slides/slide6.xml><?xml version="1.0" encoding="utf-8"?>
 <p:sld xmlns:a="http://schemas.openxmlformats.org/drawingml/2006/main" xmlns:p="http://schemas.openxmlformats.org/presentationml/2006/main" xmlns:r="http://schemas.openxmlformats.org/officeDocument/2006/relationships">
   <p:cSld>
     <p:spTree>
@@ -5412,7 +5546,7 @@
               </a:defRPr>
             </a:pPr>
             <a:r>
-              <a:t>USER EXPERIENCE EVIDENCE</a:t>
+              <a:t>VISUAL EVIDENCE &amp; STATUS</a:t>
             </a:r>
           </a:p>
           <a:p>
@@ -5424,7 +5558,7 @@
               </a:defRPr>
             </a:pPr>
             <a:r>
-              <a:t>Visual Walkthrough: Puzzle Voice, Star Confetti &amp; Exit Flow</a:t>
+              <a:t>Screen Status Detail: Voice Replay &amp; Star Confetti Particles</a:t>
             </a:r>
           </a:p>
         </p:txBody>
@@ -5437,8 +5571,8 @@
         </p:nvSpPr>
         <p:spPr>
           <a:xfrm>
-            <a:off x="731520" y="1463040"/>
-            <a:ext cx="3383280" cy="4754880"/>
+            <a:off x="731520" y="1371600"/>
+            <a:ext cx="5120640" cy="5029200"/>
           </a:xfrm>
           <a:prstGeom prst="roundRect">
             <a:avLst/>
@@ -5490,8 +5624,8 @@
         </p:blipFill>
         <p:spPr>
           <a:xfrm>
-            <a:off x="914400" y="2704338"/>
-            <a:ext cx="3017520" cy="1357884"/>
+            <a:off x="914400" y="1673352"/>
+            <a:ext cx="4754880" cy="2139696"/>
           </a:xfrm>
           <a:prstGeom prst="rect">
             <a:avLst/>
@@ -5506,8 +5640,8 @@
         </p:nvSpPr>
         <p:spPr>
           <a:xfrm>
-            <a:off x="914400" y="5212080"/>
-            <a:ext cx="3017520" cy="1005840"/>
+            <a:off x="914400" y="4023360"/>
+            <a:ext cx="4754880" cy="2286000"/>
           </a:xfrm>
           <a:prstGeom prst="rect">
             <a:avLst/>
@@ -5521,26 +5655,126 @@
           <a:lstStyle/>
           <a:p>
             <a:pPr>
-              <a:defRPr b="1" sz="1200">
-                <a:solidFill>
-                  <a:srgbClr val="263238"/>
-                </a:solidFill>
-              </a:defRPr>
-            </a:pPr>
-            <a:r>
-              <a:t>07. Voice Speaker &amp; Close 'X'</a:t>
-            </a:r>
-          </a:p>
-          <a:p>
-            <a:pPr>
-              <a:defRPr sz="1050">
-                <a:solidFill>
-                  <a:srgbClr val="64748B"/>
-                </a:solidFill>
-              </a:defRPr>
-            </a:pPr>
-            <a:r>
-              <a:t>In-game audio prompt button to repeat instructions aloud.</a:t>
+              <a:defRPr b="1" sz="1300">
+                <a:solidFill>
+                  <a:srgbClr val="212121"/>
+                </a:solidFill>
+              </a:defRPr>
+            </a:pPr>
+            <a:r>
+              <a:t>Image 07: Gameplay Voice Speaker &amp; Close 'X'</a:t>
+            </a:r>
+          </a:p>
+          <a:p>
+            <a:pPr>
+              <a:defRPr b="1" sz="1100">
+                <a:solidFill>
+                  <a:srgbClr val="2E7D32"/>
+                </a:solidFill>
+              </a:defRPr>
+            </a:pPr>
+            <a:r>
+              <a:t>Status: PASS (ACTIVE ASSISTANCE)</a:t>
+            </a:r>
+          </a:p>
+          <a:p>
+            <a:pPr>
+              <a:defRPr b="1" sz="1050">
+                <a:solidFill>
+                  <a:srgbClr val="37474F"/>
+                </a:solidFill>
+              </a:defRPr>
+            </a:pPr>
+            <a:r>
+              <a:t>• Orientation: </a:t>
+            </a:r>
+            <a:r>
+              <a:rPr b="0">
+                <a:solidFill>
+                  <a:srgbClr val="546E7A"/>
+                </a:solidFill>
+              </a:rPr>
+              <a:t>Landscape (2400×1080)</a:t>
+            </a:r>
+          </a:p>
+          <a:p>
+            <a:pPr>
+              <a:defRPr b="1" sz="1050">
+                <a:solidFill>
+                  <a:srgbClr val="37474F"/>
+                </a:solidFill>
+              </a:defRPr>
+            </a:pPr>
+            <a:r>
+              <a:t>• Voice Speaker: </a:t>
+            </a:r>
+            <a:r>
+              <a:rPr b="0">
+                <a:solidFill>
+                  <a:srgbClr val="546E7A"/>
+                </a:solidFill>
+              </a:rPr>
+              <a:t>Circular blue speaker icon in bottom-left re-reads puzzle prompt aloud</a:t>
+            </a:r>
+          </a:p>
+          <a:p>
+            <a:pPr>
+              <a:defRPr b="1" sz="1050">
+                <a:solidFill>
+                  <a:srgbClr val="37474F"/>
+                </a:solidFill>
+              </a:defRPr>
+            </a:pPr>
+            <a:r>
+              <a:t>• Close Button: </a:t>
+            </a:r>
+            <a:r>
+              <a:rPr b="0">
+                <a:solidFill>
+                  <a:srgbClr val="546E7A"/>
+                </a:solidFill>
+              </a:rPr>
+              <a:t>White circular '✕' button at top-left allows immediate exit from puzzle</a:t>
+            </a:r>
+          </a:p>
+          <a:p>
+            <a:pPr>
+              <a:defRPr b="1" sz="1050">
+                <a:solidFill>
+                  <a:srgbClr val="37474F"/>
+                </a:solidFill>
+              </a:defRPr>
+            </a:pPr>
+            <a:r>
+              <a:t>• Accessibility: </a:t>
+            </a:r>
+            <a:r>
+              <a:rPr b="0">
+                <a:solidFill>
+                  <a:srgbClr val="546E7A"/>
+                </a:solidFill>
+              </a:rPr>
+              <a:t>Allows pre-literate children to solve complex logic without adult help</a:t>
+            </a:r>
+          </a:p>
+          <a:p>
+            <a:pPr>
+              <a:defRPr b="1" sz="1050">
+                <a:solidFill>
+                  <a:srgbClr val="37474F"/>
+                </a:solidFill>
+              </a:defRPr>
+            </a:pPr>
+            <a:r>
+              <a:t>• Responsiveness: </a:t>
+            </a:r>
+            <a:r>
+              <a:rPr b="0">
+                <a:solidFill>
+                  <a:srgbClr val="546E7A"/>
+                </a:solidFill>
+              </a:rPr>
+              <a:t>Tapping speaker instantly replays clear verbal instruction</a:t>
             </a:r>
           </a:p>
         </p:txBody>
@@ -5553,8 +5787,8 @@
         </p:nvSpPr>
         <p:spPr>
           <a:xfrm>
-            <a:off x="4389120" y="1463040"/>
-            <a:ext cx="3383280" cy="4754880"/>
+            <a:off x="6217920" y="1371600"/>
+            <a:ext cx="5212080" cy="5029200"/>
           </a:xfrm>
           <a:prstGeom prst="roundRect">
             <a:avLst/>
@@ -5606,8 +5840,8 @@
         </p:blipFill>
         <p:spPr>
           <a:xfrm>
-            <a:off x="4572000" y="2704338"/>
-            <a:ext cx="3017520" cy="1357884"/>
+            <a:off x="6400800" y="1652778"/>
+            <a:ext cx="4846320" cy="2180844"/>
           </a:xfrm>
           <a:prstGeom prst="rect">
             <a:avLst/>
@@ -5622,8 +5856,8 @@
         </p:nvSpPr>
         <p:spPr>
           <a:xfrm>
-            <a:off x="4572000" y="5212080"/>
-            <a:ext cx="3017520" cy="1005840"/>
+            <a:off x="6400800" y="4023360"/>
+            <a:ext cx="4846320" cy="2286000"/>
           </a:xfrm>
           <a:prstGeom prst="rect">
             <a:avLst/>
@@ -5637,40 +5871,205 @@
           <a:lstStyle/>
           <a:p>
             <a:pPr>
-              <a:defRPr b="1" sz="1200">
-                <a:solidFill>
-                  <a:srgbClr val="263238"/>
-                </a:solidFill>
-              </a:defRPr>
-            </a:pPr>
-            <a:r>
-              <a:t>08. Confetti &amp; Star Score</a:t>
-            </a:r>
-          </a:p>
-          <a:p>
-            <a:pPr>
-              <a:defRPr sz="1050">
-                <a:solidFill>
-                  <a:srgbClr val="64748B"/>
-                </a:solidFill>
-              </a:defRPr>
-            </a:pPr>
-            <a:r>
-              <a:t>Explosion of colorful star confetti rewarding +4 ⭐.</a:t>
-            </a:r>
-          </a:p>
-        </p:txBody>
-      </p:sp>
-      <p:sp>
-        <p:nvSpPr>
-          <p:cNvPr id="9" name="Rounded Rectangle 8"/>
+              <a:defRPr b="1" sz="1300">
+                <a:solidFill>
+                  <a:srgbClr val="212121"/>
+                </a:solidFill>
+              </a:defRPr>
+            </a:pPr>
+            <a:r>
+              <a:t>Image 08: Star Confetti Particles &amp; Score Reward</a:t>
+            </a:r>
+          </a:p>
+          <a:p>
+            <a:pPr>
+              <a:defRPr b="1" sz="1100">
+                <a:solidFill>
+                  <a:srgbClr val="2E7D32"/>
+                </a:solidFill>
+              </a:defRPr>
+            </a:pPr>
+            <a:r>
+              <a:t>Status: PASS (VERIFIED REWARD FX)</a:t>
+            </a:r>
+          </a:p>
+          <a:p>
+            <a:pPr>
+              <a:defRPr b="1" sz="1050">
+                <a:solidFill>
+                  <a:srgbClr val="37474F"/>
+                </a:solidFill>
+              </a:defRPr>
+            </a:pPr>
+            <a:r>
+              <a:t>• Reward Type: </a:t>
+            </a:r>
+            <a:r>
+              <a:rPr b="0">
+                <a:solidFill>
+                  <a:srgbClr val="546E7A"/>
+                </a:solidFill>
+              </a:rPr>
+              <a:t>Immediate numerical score boost ('+4 ⭐') with golden halo glow</a:t>
+            </a:r>
+          </a:p>
+          <a:p>
+            <a:pPr>
+              <a:defRPr b="1" sz="1050">
+                <a:solidFill>
+                  <a:srgbClr val="37474F"/>
+                </a:solidFill>
+              </a:defRPr>
+            </a:pPr>
+            <a:r>
+              <a:t>• Particle Effect: </a:t>
+            </a:r>
+            <a:r>
+              <a:rPr b="0">
+                <a:solidFill>
+                  <a:srgbClr val="546E7A"/>
+                </a:solidFill>
+              </a:rPr>
+              <a:t>Multi-colored animated star confetti shower (blue, yellow, purple, cyan)</a:t>
+            </a:r>
+          </a:p>
+          <a:p>
+            <a:pPr>
+              <a:defRPr b="1" sz="1050">
+                <a:solidFill>
+                  <a:srgbClr val="37474F"/>
+                </a:solidFill>
+              </a:defRPr>
+            </a:pPr>
+            <a:r>
+              <a:t>• Audio Cue: </a:t>
+            </a:r>
+            <a:r>
+              <a:rPr b="0">
+                <a:solidFill>
+                  <a:srgbClr val="546E7A"/>
+                </a:solidFill>
+              </a:rPr>
+              <a:t>Pleasant chime sound effect triggers upon correct solution</a:t>
+            </a:r>
+          </a:p>
+          <a:p>
+            <a:pPr>
+              <a:defRPr b="1" sz="1050">
+                <a:solidFill>
+                  <a:srgbClr val="37474F"/>
+                </a:solidFill>
+              </a:defRPr>
+            </a:pPr>
+            <a:r>
+              <a:t>• No Failure Screen: </a:t>
+            </a:r>
+            <a:r>
+              <a:rPr b="0">
+                <a:solidFill>
+                  <a:srgbClr val="546E7A"/>
+                </a:solidFill>
+              </a:rPr>
+              <a:t>Incorrect answers gently guide the child to re-try without penalty</a:t>
+            </a:r>
+          </a:p>
+          <a:p>
+            <a:pPr>
+              <a:defRPr b="1" sz="1050">
+                <a:solidFill>
+                  <a:srgbClr val="37474F"/>
+                </a:solidFill>
+              </a:defRPr>
+            </a:pPr>
+            <a:r>
+              <a:t>• Visual Polish: </a:t>
+            </a:r>
+            <a:r>
+              <a:rPr b="0">
+                <a:solidFill>
+                  <a:srgbClr val="546E7A"/>
+                </a:solidFill>
+              </a:rPr>
+              <a:t>Smooth 60fps physics-based confetti particle dispersal</a:t>
+            </a:r>
+          </a:p>
+        </p:txBody>
+      </p:sp>
+    </p:spTree>
+  </p:cSld>
+  <p:clrMapOvr>
+    <a:masterClrMapping/>
+  </p:clrMapOvr>
+</p:sld>
+</file>
+
+<file path=ppt/slides/slide7.xml><?xml version="1.0" encoding="utf-8"?>
+<p:sld xmlns:a="http://schemas.openxmlformats.org/drawingml/2006/main" xmlns:p="http://schemas.openxmlformats.org/presentationml/2006/main" xmlns:r="http://schemas.openxmlformats.org/officeDocument/2006/relationships">
+  <p:cSld>
+    <p:spTree>
+      <p:nvGrpSpPr>
+        <p:cNvPr id="1" name=""/>
+        <p:cNvGrpSpPr/>
+        <p:nvPr/>
+      </p:nvGrpSpPr>
+      <p:grpSpPr/>
+      <p:sp>
+        <p:nvSpPr>
+          <p:cNvPr id="2" name="TextBox 1"/>
+          <p:cNvSpPr txBox="1"/>
+          <p:nvPr/>
+        </p:nvSpPr>
+        <p:spPr>
+          <a:xfrm>
+            <a:off x="731520" y="365760"/>
+            <a:ext cx="10698480" cy="822960"/>
+          </a:xfrm>
+          <a:prstGeom prst="rect">
+            <a:avLst/>
+          </a:prstGeom>
+          <a:noFill/>
+        </p:spPr>
+        <p:txBody>
+          <a:bodyPr wrap="square" lIns="0" tIns="0" rIns="0" bIns="0">
+            <a:spAutoFit/>
+          </a:bodyPr>
+          <a:lstStyle/>
+          <a:p>
+            <a:pPr>
+              <a:defRPr sz="1100" b="1">
+                <a:solidFill>
+                  <a:srgbClr val="78909C"/>
+                </a:solidFill>
+              </a:defRPr>
+            </a:pPr>
+            <a:r>
+              <a:t>VISUAL EVIDENCE &amp; STATUS</a:t>
+            </a:r>
+          </a:p>
+          <a:p>
+            <a:pPr>
+              <a:defRPr sz="2200" b="1">
+                <a:solidFill>
+                  <a:srgbClr val="212121"/>
+                </a:solidFill>
+              </a:defRPr>
+            </a:pPr>
+            <a:r>
+              <a:t>Screen Status Detail: Exit Modal &amp; Navigation Feedback</a:t>
+            </a:r>
+          </a:p>
+        </p:txBody>
+      </p:sp>
+      <p:sp>
+        <p:nvSpPr>
+          <p:cNvPr id="3" name="Rounded Rectangle 2"/>
           <p:cNvSpPr/>
           <p:nvPr/>
         </p:nvSpPr>
         <p:spPr>
           <a:xfrm>
-            <a:off x="8046720" y="1463040"/>
-            <a:ext cx="3383280" cy="4754880"/>
+            <a:off x="731520" y="1371600"/>
+            <a:ext cx="5120640" cy="5029200"/>
           </a:xfrm>
           <a:prstGeom prst="roundRect">
             <a:avLst/>
@@ -5708,22 +6107,22 @@
       </p:sp>
       <p:pic>
         <p:nvPicPr>
-          <p:cNvPr id="10" name="Picture 9" descr="09_exit_close_modal.png"/>
+          <p:cNvPr id="4" name="Picture 3" descr="09_exit_close_modal.png"/>
           <p:cNvPicPr>
             <a:picLocks noChangeAspect="1"/>
           </p:cNvPicPr>
           <p:nvPr/>
         </p:nvPicPr>
         <p:blipFill>
-          <a:blip r:embed="rId4"/>
+          <a:blip r:embed="rId2"/>
           <a:stretch>
             <a:fillRect/>
           </a:stretch>
         </p:blipFill>
         <p:spPr>
           <a:xfrm>
-            <a:off x="8229600" y="2704338"/>
-            <a:ext cx="3017520" cy="1357884"/>
+            <a:off x="914400" y="1673352"/>
+            <a:ext cx="4754880" cy="2139696"/>
           </a:xfrm>
           <a:prstGeom prst="rect">
             <a:avLst/>
@@ -5732,14 +6131,14 @@
       </p:pic>
       <p:sp>
         <p:nvSpPr>
-          <p:cNvPr id="11" name="TextBox 10"/>
+          <p:cNvPr id="5" name="TextBox 4"/>
           <p:cNvSpPr txBox="1"/>
           <p:nvPr/>
         </p:nvSpPr>
         <p:spPr>
           <a:xfrm>
-            <a:off x="8229600" y="5212080"/>
-            <a:ext cx="3017520" cy="1005840"/>
+            <a:off x="914400" y="4023360"/>
+            <a:ext cx="4754880" cy="2286000"/>
           </a:xfrm>
           <a:prstGeom prst="rect">
             <a:avLst/>
@@ -5753,105 +6152,140 @@
           <a:lstStyle/>
           <a:p>
             <a:pPr>
-              <a:defRPr b="1" sz="1200">
-                <a:solidFill>
-                  <a:srgbClr val="263238"/>
-                </a:solidFill>
-              </a:defRPr>
-            </a:pPr>
-            <a:r>
-              <a:t>09. Exit Feedback Modal</a:t>
-            </a:r>
-          </a:p>
-          <a:p>
-            <a:pPr>
-              <a:defRPr sz="1050">
-                <a:solidFill>
-                  <a:srgbClr val="64748B"/>
-                </a:solidFill>
-              </a:defRPr>
-            </a:pPr>
-            <a:r>
-              <a:t>Friendly feedback modal with prominent close 'X' button.</a:t>
-            </a:r>
-          </a:p>
-        </p:txBody>
-      </p:sp>
-    </p:spTree>
-  </p:cSld>
-  <p:clrMapOvr>
-    <a:masterClrMapping/>
-  </p:clrMapOvr>
-</p:sld>
-</file>
-
-<file path=ppt/slides/slide8.xml><?xml version="1.0" encoding="utf-8"?>
-<p:sld xmlns:a="http://schemas.openxmlformats.org/drawingml/2006/main" xmlns:p="http://schemas.openxmlformats.org/presentationml/2006/main" xmlns:r="http://schemas.openxmlformats.org/officeDocument/2006/relationships">
-  <p:cSld>
-    <p:spTree>
-      <p:nvGrpSpPr>
-        <p:cNvPr id="1" name=""/>
-        <p:cNvGrpSpPr/>
-        <p:nvPr/>
-      </p:nvGrpSpPr>
-      <p:grpSpPr/>
-      <p:sp>
-        <p:nvSpPr>
-          <p:cNvPr id="2" name="TextBox 1"/>
-          <p:cNvSpPr txBox="1"/>
+              <a:defRPr b="1" sz="1300">
+                <a:solidFill>
+                  <a:srgbClr val="212121"/>
+                </a:solidFill>
+              </a:defRPr>
+            </a:pPr>
+            <a:r>
+              <a:t>Image 09: Exit Confirmation &amp; Feedback Modal</a:t>
+            </a:r>
+          </a:p>
+          <a:p>
+            <a:pPr>
+              <a:defRPr b="1" sz="1100">
+                <a:solidFill>
+                  <a:srgbClr val="2E7D32"/>
+                </a:solidFill>
+              </a:defRPr>
+            </a:pPr>
+            <a:r>
+              <a:t>Status: PASS (FRIENDLY DISMISS)</a:t>
+            </a:r>
+          </a:p>
+          <a:p>
+            <a:pPr>
+              <a:defRPr b="1" sz="1050">
+                <a:solidFill>
+                  <a:srgbClr val="37474F"/>
+                </a:solidFill>
+              </a:defRPr>
+            </a:pPr>
+            <a:r>
+              <a:t>• Orientation: </a:t>
+            </a:r>
+            <a:r>
+              <a:rPr b="0">
+                <a:solidFill>
+                  <a:srgbClr val="546E7A"/>
+                </a:solidFill>
+              </a:rPr>
+              <a:t>Landscape (2400×1080) overlay</a:t>
+            </a:r>
+          </a:p>
+          <a:p>
+            <a:pPr>
+              <a:defRPr b="1" sz="1050">
+                <a:solidFill>
+                  <a:srgbClr val="37474F"/>
+                </a:solidFill>
+              </a:defRPr>
+            </a:pPr>
+            <a:r>
+              <a:t>• Trigger: </a:t>
+            </a:r>
+            <a:r>
+              <a:rPr b="0">
+                <a:solidFill>
+                  <a:srgbClr val="546E7A"/>
+                </a:solidFill>
+              </a:rPr>
+              <a:t>Tapping the top-left '✕' button during active gameplay</a:t>
+            </a:r>
+          </a:p>
+          <a:p>
+            <a:pPr>
+              <a:defRPr b="1" sz="1050">
+                <a:solidFill>
+                  <a:srgbClr val="37474F"/>
+                </a:solidFill>
+              </a:defRPr>
+            </a:pPr>
+            <a:r>
+              <a:t>• UI Elements: </a:t>
+            </a:r>
+            <a:r>
+              <a:rPr b="0">
+                <a:solidFill>
+                  <a:srgbClr val="546E7A"/>
+                </a:solidFill>
+              </a:rPr>
+              <a:t>Coral-red top-right '✕' button, feedback rating stars, 'Leave' action</a:t>
+            </a:r>
+          </a:p>
+          <a:p>
+            <a:pPr>
+              <a:defRPr b="1" sz="1050">
+                <a:solidFill>
+                  <a:srgbClr val="37474F"/>
+                </a:solidFill>
+              </a:defRPr>
+            </a:pPr>
+            <a:r>
+              <a:t>• Safety Check: </a:t>
+            </a:r>
+            <a:r>
+              <a:rPr b="0">
+                <a:solidFill>
+                  <a:srgbClr val="546E7A"/>
+                </a:solidFill>
+              </a:rPr>
+              <a:t>Prevents accidental loss of puzzle progress on unintended touches</a:t>
+            </a:r>
+          </a:p>
+          <a:p>
+            <a:pPr>
+              <a:defRPr b="1" sz="1050">
+                <a:solidFill>
+                  <a:srgbClr val="37474F"/>
+                </a:solidFill>
+              </a:defRPr>
+            </a:pPr>
+            <a:r>
+              <a:t>• Dismissal: </a:t>
+            </a:r>
+            <a:r>
+              <a:rPr b="0">
+                <a:solidFill>
+                  <a:srgbClr val="546E7A"/>
+                </a:solidFill>
+              </a:rPr>
+              <a:t>Tapping '✕' immediately returns child to active puzzle without state loss</a:t>
+            </a:r>
+          </a:p>
+        </p:txBody>
+      </p:sp>
+      <p:sp>
+        <p:nvSpPr>
+          <p:cNvPr id="6" name="Rounded Rectangle 5"/>
+          <p:cNvSpPr/>
           <p:nvPr/>
         </p:nvSpPr>
         <p:spPr>
           <a:xfrm>
-            <a:off x="731520" y="365760"/>
-            <a:ext cx="10698480" cy="822960"/>
-          </a:xfrm>
-          <a:prstGeom prst="rect">
-            <a:avLst/>
-          </a:prstGeom>
-          <a:noFill/>
-        </p:spPr>
-        <p:txBody>
-          <a:bodyPr wrap="square" lIns="0" tIns="0" rIns="0" bIns="0">
-            <a:spAutoFit/>
-          </a:bodyPr>
-          <a:lstStyle/>
-          <a:p>
-            <a:pPr>
-              <a:defRPr sz="1100" b="1">
-                <a:solidFill>
-                  <a:srgbClr val="78909C"/>
-                </a:solidFill>
-              </a:defRPr>
-            </a:pPr>
-            <a:r>
-              <a:t>STRATEGIC RECOMMENDATIONS</a:t>
-            </a:r>
-          </a:p>
-          <a:p>
-            <a:pPr>
-              <a:defRPr sz="2200" b="1">
-                <a:solidFill>
-                  <a:srgbClr val="212121"/>
-                </a:solidFill>
-              </a:defRPr>
-            </a:pPr>
-            <a:r>
-              <a:t>Key Recommendations &amp; QA Summary</a:t>
-            </a:r>
-          </a:p>
-        </p:txBody>
-      </p:sp>
-      <p:sp>
-        <p:nvSpPr>
-          <p:cNvPr id="3" name="Rounded Rectangle 2"/>
-          <p:cNvSpPr/>
-          <p:nvPr/>
-        </p:nvSpPr>
-        <p:spPr>
-          <a:xfrm>
-            <a:off x="731520" y="1463040"/>
-            <a:ext cx="5120640" cy="4754880"/>
+            <a:off x="6217920" y="1371600"/>
+            <a:ext cx="5212080" cy="5029200"/>
           </a:xfrm>
           <a:prstGeom prst="roundRect">
             <a:avLst/>
@@ -5889,14 +6323,14 @@
       </p:sp>
       <p:sp>
         <p:nvSpPr>
-          <p:cNvPr id="4" name="TextBox 3"/>
+          <p:cNvPr id="7" name="TextBox 6"/>
           <p:cNvSpPr txBox="1"/>
           <p:nvPr/>
         </p:nvSpPr>
         <p:spPr>
           <a:xfrm>
-            <a:off x="1005840" y="1737360"/>
-            <a:ext cx="4572000" cy="4206240"/>
+            <a:off x="6492240" y="1645920"/>
+            <a:ext cx="4663440" cy="4480560"/>
           </a:xfrm>
           <a:prstGeom prst="rect">
             <a:avLst/>
@@ -5910,226 +6344,114 @@
           <a:lstStyle/>
           <a:p>
             <a:pPr>
-              <a:defRPr b="1" sz="1600">
-                <a:solidFill>
-                  <a:srgbClr val="C62828"/>
-                </a:solidFill>
-              </a:defRPr>
-            </a:pPr>
-            <a:r>
-              <a:t>Identified UX &amp; Localization Opportunities</a:t>
-            </a:r>
-          </a:p>
-          <a:p>
-            <a:pPr>
-              <a:defRPr b="1" sz="1200">
-                <a:solidFill>
-                  <a:srgbClr val="C62828"/>
-                </a:solidFill>
-              </a:defRPr>
-            </a:pPr>
-            <a:r>
-              <a:t>▲  Multilingual Parental PIN</a:t>
-            </a:r>
-          </a:p>
-          <a:p>
-            <a:pPr>
-              <a:defRPr sz="1100">
-                <a:solidFill>
-                  <a:srgbClr val="64748B"/>
-                </a:solidFill>
-              </a:defRPr>
-            </a:pPr>
-            <a:r>
-              <a:t>    Parental challenge displays English words ('THREE FIVE SIX'). Supporting regional languages (Hindi, etc.) or mathematical operations would benefit non-English speaking parents.</a:t>
-            </a:r>
-          </a:p>
-          <a:p>
-            <a:pPr>
-              <a:defRPr b="1" sz="1200">
-                <a:solidFill>
-                  <a:srgbClr val="C62828"/>
-                </a:solidFill>
-              </a:defRPr>
-            </a:pPr>
-            <a:r>
-              <a:t>▲  Direct In-Puzzle Mute Toggle</a:t>
-            </a:r>
-          </a:p>
-          <a:p>
-            <a:pPr>
-              <a:defRPr sz="1100">
-                <a:solidFill>
-                  <a:srgbClr val="64748B"/>
-                </a:solidFill>
-              </a:defRPr>
-            </a:pPr>
-            <a:r>
-              <a:t>    While music can be toggled in parent settings, an in-game sound toggle alongside the voice replay speaker would give immediate volume control.</a:t>
-            </a:r>
-          </a:p>
-          <a:p>
-            <a:pPr>
-              <a:defRPr b="1" sz="1200">
-                <a:solidFill>
-                  <a:srgbClr val="C62828"/>
-                </a:solidFill>
-              </a:defRPr>
-            </a:pPr>
-            <a:r>
-              <a:t>▲  Confetti Particle Duration</a:t>
-            </a:r>
-          </a:p>
-          <a:p>
-            <a:pPr>
-              <a:defRPr sz="1100">
-                <a:solidFill>
-                  <a:srgbClr val="64748B"/>
-                </a:solidFill>
-              </a:defRPr>
-            </a:pPr>
-            <a:r>
-              <a:t>    Celebratory confetti animation is visually spectacular but could allow instant tap-to-skip for rapid puzzle solvers.</a:t>
-            </a:r>
-          </a:p>
-        </p:txBody>
-      </p:sp>
-      <p:sp>
-        <p:nvSpPr>
-          <p:cNvPr id="5" name="Rounded Rectangle 4"/>
-          <p:cNvSpPr/>
-          <p:nvPr/>
-        </p:nvSpPr>
-        <p:spPr>
-          <a:xfrm>
-            <a:off x="6217920" y="1463040"/>
-            <a:ext cx="5212080" cy="4754880"/>
-          </a:xfrm>
-          <a:prstGeom prst="roundRect">
-            <a:avLst/>
-          </a:prstGeom>
-          <a:solidFill>
-            <a:srgbClr val="FFFFFF"/>
-          </a:solidFill>
-          <a:ln w="12700">
-            <a:solidFill>
-              <a:srgbClr val="DCE0E6"/>
-            </a:solidFill>
-          </a:ln>
-        </p:spPr>
-        <p:style>
-          <a:lnRef idx="1">
-            <a:schemeClr val="accent1"/>
-          </a:lnRef>
-          <a:fillRef idx="3">
-            <a:schemeClr val="accent1"/>
-          </a:fillRef>
-          <a:effectRef idx="2">
-            <a:schemeClr val="accent1"/>
-          </a:effectRef>
-          <a:fontRef idx="minor">
-            <a:schemeClr val="lt1"/>
-          </a:fontRef>
-        </p:style>
-        <p:txBody>
-          <a:bodyPr rtlCol="0" anchor="ctr"/>
-          <a:lstStyle/>
-          <a:p>
-            <a:pPr algn="ctr"/>
-          </a:p>
-        </p:txBody>
-      </p:sp>
-      <p:sp>
-        <p:nvSpPr>
-          <p:cNvPr id="6" name="TextBox 5"/>
-          <p:cNvSpPr txBox="1"/>
-          <p:nvPr/>
-        </p:nvSpPr>
-        <p:spPr>
-          <a:xfrm>
-            <a:off x="6492240" y="1737360"/>
-            <a:ext cx="4663440" cy="4206240"/>
-          </a:xfrm>
-          <a:prstGeom prst="rect">
-            <a:avLst/>
-          </a:prstGeom>
-          <a:noFill/>
-        </p:spPr>
-        <p:txBody>
-          <a:bodyPr wrap="square">
-            <a:spAutoFit/>
-          </a:bodyPr>
-          <a:lstStyle/>
-          <a:p>
-            <a:pPr>
-              <a:defRPr b="1" sz="1600">
+              <a:defRPr b="1" sz="1400">
+                <a:solidFill>
+                  <a:srgbClr val="1565C0"/>
+                </a:solidFill>
+              </a:defRPr>
+            </a:pPr>
+            <a:r>
+              <a:t>LOGICLIKE: ABC &amp; MATH — AUDIT SUMMARY</a:t>
+            </a:r>
+          </a:p>
+          <a:p>
+            <a:pPr>
+              <a:defRPr b="1" sz="1100">
                 <a:solidFill>
                   <a:srgbClr val="2E7D32"/>
                 </a:solidFill>
               </a:defRPr>
             </a:pPr>
             <a:r>
-              <a:t>Final QA Verdict</a:t>
-            </a:r>
-          </a:p>
-          <a:p>
-            <a:pPr>
-              <a:defRPr b="1" sz="1300">
+              <a:t>✔  Orientation Model: </a:t>
+            </a:r>
+            <a:r>
+              <a:rPr b="0">
+                <a:solidFill>
+                  <a:srgbClr val="37474F"/>
+                </a:solidFill>
+              </a:rPr>
+              <a:t>Adaptive Hybrid. Launch, onboarding, paywalls &amp; settings run in Portrait (1080×2400). Main curriculum tracks and puzzles run in Landscape (2400×1080).</a:t>
+            </a:r>
+          </a:p>
+          <a:p>
+            <a:pPr>
+              <a:defRPr b="1" sz="1100">
                 <a:solidFill>
                   <a:srgbClr val="2E7D32"/>
                 </a:solidFill>
               </a:defRPr>
             </a:pPr>
             <a:r>
-              <a:t>STATUS: CERTIFIED CHILD-READY (PREMIUM UX)</a:t>
-            </a:r>
-          </a:p>
-          <a:p>
-            <a:pPr>
-              <a:defRPr sz="1100">
+              <a:t>✔  Parental Security: </a:t>
+            </a:r>
+            <a:r>
+              <a:rPr b="0">
                 <a:solidFill>
                   <a:srgbClr val="37474F"/>
                 </a:solidFill>
-              </a:defRPr>
-            </a:pPr>
-            <a:r>
-              <a:t>✔  LogicLike exhibits best-in-class visual polish, high-frame-rate animations, and child accessibility.</a:t>
-            </a:r>
-          </a:p>
-          <a:p>
-            <a:pPr>
-              <a:defRPr sz="1100">
+              </a:rPr>
+              <a:t>Word-PIN challenge ('THREE FIVE SIX') successfully prevents child bypass into subscription or settings.</a:t>
+            </a:r>
+          </a:p>
+          <a:p>
+            <a:pPr>
+              <a:defRPr b="1" sz="1100">
+                <a:solidFill>
+                  <a:srgbClr val="2E7D32"/>
+                </a:solidFill>
+              </a:defRPr>
+            </a:pPr>
+            <a:r>
+              <a:t>✔  Audio Architecture: </a:t>
+            </a:r>
+            <a:r>
+              <a:rPr b="0">
                 <a:solidFill>
                   <a:srgbClr val="37474F"/>
                 </a:solidFill>
-              </a:defRPr>
-            </a:pPr>
-            <a:r>
-              <a:t>✔  Clear audio guidance ensures pre-literate children can independently solve reasoning puzzles.</a:t>
-            </a:r>
-          </a:p>
-          <a:p>
-            <a:pPr>
-              <a:defRPr sz="1100">
+              </a:rPr>
+              <a:t>Dedicated 'Music' toggle in settings; independent in-game voice replay speaker on all puzzles.</a:t>
+            </a:r>
+          </a:p>
+          <a:p>
+            <a:pPr>
+              <a:defRPr b="1" sz="1100">
+                <a:solidFill>
+                  <a:srgbClr val="2E7D32"/>
+                </a:solidFill>
+              </a:defRPr>
+            </a:pPr>
+            <a:r>
+              <a:t>✔  Navigation Quality: </a:t>
+            </a:r>
+            <a:r>
+              <a:rPr b="0">
                 <a:solidFill>
                   <a:srgbClr val="37474F"/>
                 </a:solidFill>
-              </a:defRPr>
-            </a:pPr>
-            <a:r>
-              <a:t>✔  Zero dark UX patterns: paywalls and dialogs feature prominent, unmistakable close 'X' buttons.</a:t>
-            </a:r>
-          </a:p>
-          <a:p>
-            <a:pPr>
-              <a:defRPr sz="1100">
+              </a:rPr>
+              <a:t>Zero dark traps. Every overlay (paywall, puzzle, exit dialog) has an explicit '✕' button.</a:t>
+            </a:r>
+          </a:p>
+          <a:p>
+            <a:pPr>
+              <a:defRPr b="1" sz="1100">
+                <a:solidFill>
+                  <a:srgbClr val="2E7D32"/>
+                </a:solidFill>
+              </a:defRPr>
+            </a:pPr>
+            <a:r>
+              <a:t>✔  Celebration FX: </a:t>
+            </a:r>
+            <a:r>
+              <a:rPr b="0">
                 <a:solidFill>
                   <a:srgbClr val="37474F"/>
                 </a:solidFill>
-              </a:defRPr>
-            </a:pPr>
-            <a:r>
-              <a:t>✔  Star score (+4 ⭐) and confetti particles deliver immediate positive dopamine feedback.</a:t>
+              </a:rPr>
+              <a:t>High-fidelity confetti particle shower and immediate +4 ⭐ reward feedback upon puzzle completion.</a:t>
             </a:r>
           </a:p>
         </p:txBody>

</xml_diff>